<commit_message>
Update PPTX: Jason, Luana, Focus Group real data
</commit_message>
<xml_diff>
--- a/CheckAuto_Presentacion.pptx
+++ b/CheckAuto_Presentacion.pptx
@@ -8621,18 +8621,20 @@
         </p:nvSpPr>
         <p:spPr>
           <a:xfrm>
-            <a:off x="365760" y="1005840"/>
-            <a:ext cx="2011680" cy="2011680"/>
-          </a:xfrm>
-          <a:prstGeom prst="ellipse">
-            <a:avLst/>
+            <a:off x="320040" y="960120"/>
+            <a:ext cx="2194560" cy="2331720"/>
+          </a:xfrm>
+          <a:prstGeom prst="roundRect">
+            <a:avLst>
+              <a:gd name="adj" fmla="val 6250"/>
+            </a:avLst>
           </a:prstGeom>
           <a:solidFill>
-            <a:srgbClr val="1E4D8C"/>
+            <a:srgbClr val="EBF2FC"/>
           </a:solidFill>
-          <a:ln w="38100">
+          <a:ln w="31750">
             <a:solidFill>
-              <a:srgbClr val="1B3A6B"/>
+              <a:srgbClr val="1E4D8C"/>
             </a:solidFill>
             <a:prstDash val="solid"/>
           </a:ln>
@@ -8653,8 +8655,8 @@
         </p:nvSpPr>
         <p:spPr>
           <a:xfrm>
-            <a:off x="365760" y="1005840"/>
-            <a:ext cx="2011680" cy="2011680"/>
+            <a:off x="320040" y="1417320"/>
+            <a:ext cx="2194560" cy="640080"/>
           </a:xfrm>
           <a:prstGeom prst="rect">
             <a:avLst/>
@@ -8670,14 +8672,14 @@
               <a:buNone/>
             </a:pPr>
             <a:r>
-              <a:rPr lang="en-US" sz="6000" dirty="0">
+              <a:rPr lang="en-US" sz="3200" dirty="0">
                 <a:solidFill>
                   <a:srgbClr val="000000"/>
                 </a:solidFill>
               </a:rPr>
-              <a:t>👤</a:t>
-            </a:r>
-            <a:endParaRPr lang="en-US" sz="6000" dirty="0"/>
+              <a:t>📷</a:t>
+            </a:r>
+            <a:endParaRPr lang="en-US" sz="3200" dirty="0"/>
           </a:p>
         </p:txBody>
       </p:sp>
@@ -8689,105 +8691,8 @@
         </p:nvSpPr>
         <p:spPr>
           <a:xfrm>
-            <a:off x="2560320" y="1051560"/>
-            <a:ext cx="6217920" cy="548640"/>
-          </a:xfrm>
-          <a:prstGeom prst="rect">
-            <a:avLst/>
-          </a:prstGeom>
-          <a:noFill/>
-          <a:ln/>
-        </p:spPr>
-        <p:txBody>
-          <a:bodyPr wrap="square" lIns="0" tIns="0" rIns="0" bIns="0" rtlCol="0" anchor="ctr"/>
-          <a:lstStyle/>
-          <a:p>
-            <a:pPr indent="0" marL="0">
-              <a:buNone/>
-            </a:pPr>
-            <a:r>
-              <a:rPr lang="en-US" sz="2200" b="1" dirty="0">
-                <a:solidFill>
-                  <a:srgbClr val="1B3A6B"/>
-                </a:solidFill>
-              </a:rPr>
-              <a:t>Carlos Mendoza</a:t>
-            </a:r>
-            <a:endParaRPr lang="en-US" sz="2200" dirty="0"/>
-          </a:p>
-        </p:txBody>
-      </p:sp>
-      <p:sp>
-        <p:nvSpPr>
-          <p:cNvPr id="8" name="Text 6"/>
-          <p:cNvSpPr/>
-          <p:nvPr/>
-        </p:nvSpPr>
-        <p:spPr>
-          <a:xfrm>
-            <a:off x="2560320" y="1600200"/>
-            <a:ext cx="6217920" cy="411480"/>
-          </a:xfrm>
-          <a:prstGeom prst="rect">
-            <a:avLst/>
-          </a:prstGeom>
-          <a:noFill/>
-          <a:ln/>
-        </p:spPr>
-        <p:txBody>
-          <a:bodyPr wrap="square" lIns="0" tIns="0" rIns="0" bIns="0" rtlCol="0" anchor="ctr"/>
-          <a:lstStyle/>
-          <a:p>
-            <a:pPr indent="0" marL="0">
-              <a:buNone/>
-            </a:pPr>
-            <a:r>
-              <a:rPr lang="en-US" sz="1300" dirty="0">
-                <a:solidFill>
-                  <a:srgbClr val="64748B"/>
-                </a:solidFill>
-              </a:rPr>
-              <a:t>34 años  |  Vendedor de vehículos independiente</a:t>
-            </a:r>
-            <a:endParaRPr lang="en-US" sz="1300" dirty="0"/>
-          </a:p>
-        </p:txBody>
-      </p:sp>
-      <p:sp>
-        <p:nvSpPr>
-          <p:cNvPr id="9" name="Shape 7"/>
-          <p:cNvSpPr/>
-          <p:nvPr/>
-        </p:nvSpPr>
-        <p:spPr>
-          <a:xfrm>
-            <a:off x="2560320" y="2057400"/>
-            <a:ext cx="5943600" cy="36576"/>
-          </a:xfrm>
-          <a:prstGeom prst="rect">
-            <a:avLst/>
-          </a:prstGeom>
-          <a:solidFill>
-            <a:srgbClr val="F97316"/>
-          </a:solidFill>
-          <a:ln w="12700">
-            <a:solidFill>
-              <a:srgbClr val="F97316"/>
-            </a:solidFill>
-            <a:prstDash val="solid"/>
-          </a:ln>
-        </p:spPr>
-      </p:sp>
-      <p:sp>
-        <p:nvSpPr>
-          <p:cNvPr id="10" name="Text 8"/>
-          <p:cNvSpPr/>
-          <p:nvPr/>
-        </p:nvSpPr>
-        <p:spPr>
-          <a:xfrm>
-            <a:off x="365760" y="3063240"/>
-            <a:ext cx="2011680" cy="548640"/>
+            <a:off x="320040" y="2103120"/>
+            <a:ext cx="2194560" cy="640080"/>
           </a:xfrm>
           <a:prstGeom prst="rect">
             <a:avLst/>
@@ -8805,10 +8710,10 @@
             <a:r>
               <a:rPr lang="en-US" sz="1000" i="1" dirty="0">
                 <a:solidFill>
-                  <a:srgbClr val="64748B"/>
-                </a:solidFill>
-              </a:rPr>
-              <a:t>Foto del</a:t>
+                  <a:srgbClr val="1E4D8C"/>
+                </a:solidFill>
+              </a:rPr>
+              <a:t>Insertar foto</a:t>
             </a:r>
             <a:endParaRPr lang="en-US" sz="1000" dirty="0"/>
           </a:p>
@@ -8819,10 +8724,10 @@
             <a:r>
               <a:rPr lang="en-US" sz="1000" i="1" dirty="0">
                 <a:solidFill>
-                  <a:srgbClr val="64748B"/>
-                </a:solidFill>
-              </a:rPr>
-              <a:t>Entrevistado</a:t>
+                  <a:srgbClr val="1E4D8C"/>
+                </a:solidFill>
+              </a:rPr>
+              <a:t>del entrevistado</a:t>
             </a:r>
             <a:endParaRPr lang="en-US" sz="1000" dirty="0"/>
           </a:p>
@@ -8830,18 +8735,18 @@
       </p:sp>
       <p:sp>
         <p:nvSpPr>
-          <p:cNvPr id="11" name="Shape 9"/>
-          <p:cNvSpPr/>
-          <p:nvPr/>
-        </p:nvSpPr>
-        <p:spPr>
-          <a:xfrm>
-            <a:off x="274320" y="2240280"/>
-            <a:ext cx="4114800" cy="2606040"/>
+          <p:cNvPr id="8" name="Shape 6"/>
+          <p:cNvSpPr/>
+          <p:nvPr/>
+        </p:nvSpPr>
+        <p:spPr>
+          <a:xfrm>
+            <a:off x="2697480" y="960120"/>
+            <a:ext cx="6126480" cy="1371600"/>
           </a:xfrm>
           <a:prstGeom prst="roundRect">
             <a:avLst>
-              <a:gd name="adj" fmla="val 3509"/>
+              <a:gd name="adj" fmla="val 6667"/>
             </a:avLst>
           </a:prstGeom>
           <a:solidFill>
@@ -8864,14 +8769,14 @@
       </p:sp>
       <p:sp>
         <p:nvSpPr>
-          <p:cNvPr id="12" name="Text 10"/>
-          <p:cNvSpPr/>
-          <p:nvPr/>
-        </p:nvSpPr>
-        <p:spPr>
-          <a:xfrm>
-            <a:off x="457200" y="2331720"/>
-            <a:ext cx="3749040" cy="411480"/>
+          <p:cNvPr id="9" name="Text 7"/>
+          <p:cNvSpPr/>
+          <p:nvPr/>
+        </p:nvSpPr>
+        <p:spPr>
+          <a:xfrm>
+            <a:off x="2834640" y="1005840"/>
+            <a:ext cx="5852160" cy="594360"/>
           </a:xfrm>
           <a:prstGeom prst="rect">
             <a:avLst/>
@@ -8887,12 +8792,73 @@
               <a:buNone/>
             </a:pPr>
             <a:r>
-              <a:rPr lang="en-US" sz="1300" b="1" dirty="0">
-                <a:solidFill>
-                  <a:srgbClr val="16A34A"/>
-                </a:solidFill>
-              </a:rPr>
-              <a:t>✅  Insights Positivos</a:t>
+              <a:rPr lang="en-US" sz="2600" b="1" dirty="0">
+                <a:solidFill>
+                  <a:srgbClr val="1B3A6B"/>
+                </a:solidFill>
+              </a:rPr>
+              <a:t>Jason</a:t>
+            </a:r>
+            <a:endParaRPr lang="en-US" sz="2600" dirty="0"/>
+          </a:p>
+        </p:txBody>
+      </p:sp>
+      <p:sp>
+        <p:nvSpPr>
+          <p:cNvPr id="10" name="Shape 8"/>
+          <p:cNvSpPr/>
+          <p:nvPr/>
+        </p:nvSpPr>
+        <p:spPr>
+          <a:xfrm>
+            <a:off x="2834640" y="1627632"/>
+            <a:ext cx="1097280" cy="36576"/>
+          </a:xfrm>
+          <a:prstGeom prst="rect">
+            <a:avLst/>
+          </a:prstGeom>
+          <a:solidFill>
+            <a:srgbClr val="F97316"/>
+          </a:solidFill>
+          <a:ln w="12700">
+            <a:solidFill>
+              <a:srgbClr val="F97316"/>
+            </a:solidFill>
+            <a:prstDash val="solid"/>
+          </a:ln>
+        </p:spPr>
+      </p:sp>
+      <p:sp>
+        <p:nvSpPr>
+          <p:cNvPr id="11" name="Text 9"/>
+          <p:cNvSpPr/>
+          <p:nvPr/>
+        </p:nvSpPr>
+        <p:spPr>
+          <a:xfrm>
+            <a:off x="2834640" y="1691640"/>
+            <a:ext cx="5852160" cy="502920"/>
+          </a:xfrm>
+          <a:prstGeom prst="rect">
+            <a:avLst/>
+          </a:prstGeom>
+          <a:noFill/>
+          <a:ln/>
+        </p:spPr>
+        <p:txBody>
+          <a:bodyPr wrap="square" lIns="0" tIns="0" rIns="0" bIns="0" rtlCol="0" anchor="ctr"/>
+          <a:lstStyle/>
+          <a:p>
+            <a:pPr indent="0" marL="0">
+              <a:buNone/>
+            </a:pPr>
+            <a:r>
+              <a:rPr lang="en-US" sz="1300" i="1" dirty="0">
+                <a:solidFill>
+                  <a:srgbClr val="64748B"/>
+                </a:solidFill>
+              </a:rPr>
+              <a:t>22 años  ·  Asistente de Ventas</a:t>
             </a:r>
             <a:endParaRPr lang="en-US" sz="1300" dirty="0"/>
           </a:p>
@@ -8900,126 +8866,18 @@
       </p:sp>
       <p:sp>
         <p:nvSpPr>
-          <p:cNvPr id="13" name="Text 11"/>
-          <p:cNvSpPr/>
-          <p:nvPr/>
-        </p:nvSpPr>
-        <p:spPr>
-          <a:xfrm>
-            <a:off x="457200" y="2788920"/>
-            <a:ext cx="3749040" cy="548640"/>
-          </a:xfrm>
-          <a:prstGeom prst="rect">
-            <a:avLst/>
-          </a:prstGeom>
-          <a:noFill/>
-          <a:ln/>
-        </p:spPr>
-        <p:txBody>
-          <a:bodyPr wrap="square" rtlCol="0" anchor="ctr"/>
-          <a:lstStyle/>
-          <a:p>
-            <a:pPr indent="0" marL="0">
-              <a:buNone/>
-            </a:pPr>
-            <a:r>
-              <a:rPr lang="en-US" sz="1200" dirty="0">
-                <a:solidFill>
-                  <a:srgbClr val="1E293B"/>
-                </a:solidFill>
-              </a:rPr>
-              <a:t>+ Le parece excelente la idea de un servicio certificado</a:t>
-            </a:r>
-            <a:endParaRPr lang="en-US" sz="1200" dirty="0"/>
-          </a:p>
-        </p:txBody>
-      </p:sp>
-      <p:sp>
-        <p:nvSpPr>
-          <p:cNvPr id="14" name="Text 12"/>
-          <p:cNvSpPr/>
-          <p:nvPr/>
-        </p:nvSpPr>
-        <p:spPr>
-          <a:xfrm>
-            <a:off x="457200" y="3429000"/>
-            <a:ext cx="3749040" cy="548640"/>
-          </a:xfrm>
-          <a:prstGeom prst="rect">
-            <a:avLst/>
-          </a:prstGeom>
-          <a:noFill/>
-          <a:ln/>
-        </p:spPr>
-        <p:txBody>
-          <a:bodyPr wrap="square" rtlCol="0" anchor="ctr"/>
-          <a:lstStyle/>
-          <a:p>
-            <a:pPr indent="0" marL="0">
-              <a:buNone/>
-            </a:pPr>
-            <a:r>
-              <a:rPr lang="en-US" sz="1200" dirty="0">
-                <a:solidFill>
-                  <a:srgbClr val="1E293B"/>
-                </a:solidFill>
-              </a:rPr>
-              <a:t>+ Cree que aumentaría la confianza de sus compradores</a:t>
-            </a:r>
-            <a:endParaRPr lang="en-US" sz="1200" dirty="0"/>
-          </a:p>
-        </p:txBody>
-      </p:sp>
-      <p:sp>
-        <p:nvSpPr>
-          <p:cNvPr id="15" name="Text 13"/>
-          <p:cNvSpPr/>
-          <p:nvPr/>
-        </p:nvSpPr>
-        <p:spPr>
-          <a:xfrm>
-            <a:off x="457200" y="4069080"/>
-            <a:ext cx="3749040" cy="548640"/>
-          </a:xfrm>
-          <a:prstGeom prst="rect">
-            <a:avLst/>
-          </a:prstGeom>
-          <a:noFill/>
-          <a:ln/>
-        </p:spPr>
-        <p:txBody>
-          <a:bodyPr wrap="square" rtlCol="0" anchor="ctr"/>
-          <a:lstStyle/>
-          <a:p>
-            <a:pPr indent="0" marL="0">
-              <a:buNone/>
-            </a:pPr>
-            <a:r>
-              <a:rPr lang="en-US" sz="1200" dirty="0">
-                <a:solidFill>
-                  <a:srgbClr val="1E293B"/>
-                </a:solidFill>
-              </a:rPr>
-              <a:t>+ Está dispuesto a aliarse con CheckAuto</a:t>
-            </a:r>
-            <a:endParaRPr lang="en-US" sz="1200" dirty="0"/>
-          </a:p>
-        </p:txBody>
-      </p:sp>
-      <p:sp>
-        <p:nvSpPr>
-          <p:cNvPr id="16" name="Shape 14"/>
-          <p:cNvSpPr/>
-          <p:nvPr/>
-        </p:nvSpPr>
-        <p:spPr>
-          <a:xfrm>
-            <a:off x="4754880" y="2240280"/>
-            <a:ext cx="4114800" cy="2606040"/>
+          <p:cNvPr id="12" name="Shape 10"/>
+          <p:cNvSpPr/>
+          <p:nvPr/>
+        </p:nvSpPr>
+        <p:spPr>
+          <a:xfrm>
+            <a:off x="274320" y="2514600"/>
+            <a:ext cx="4206240" cy="2377440"/>
           </a:xfrm>
           <a:prstGeom prst="roundRect">
             <a:avLst>
-              <a:gd name="adj" fmla="val 3509"/>
+              <a:gd name="adj" fmla="val 3846"/>
             </a:avLst>
           </a:prstGeom>
           <a:solidFill>
@@ -9027,7 +8885,7 @@
           </a:solidFill>
           <a:ln w="12700">
             <a:solidFill>
-              <a:srgbClr val="DCE8F5"/>
+              <a:srgbClr val="D1FAE5"/>
             </a:solidFill>
             <a:prstDash val="solid"/>
           </a:ln>
@@ -9042,14 +8900,14 @@
       </p:sp>
       <p:sp>
         <p:nvSpPr>
-          <p:cNvPr id="17" name="Text 15"/>
-          <p:cNvSpPr/>
-          <p:nvPr/>
-        </p:nvSpPr>
-        <p:spPr>
-          <a:xfrm>
-            <a:off x="4937760" y="2331720"/>
-            <a:ext cx="3749040" cy="411480"/>
+          <p:cNvPr id="13" name="Text 11"/>
+          <p:cNvSpPr/>
+          <p:nvPr/>
+        </p:nvSpPr>
+        <p:spPr>
+          <a:xfrm>
+            <a:off x="457200" y="2587752"/>
+            <a:ext cx="3840480" cy="384048"/>
           </a:xfrm>
           <a:prstGeom prst="rect">
             <a:avLst/>
@@ -9067,10 +8925,188 @@
             <a:r>
               <a:rPr lang="en-US" sz="1300" b="1" dirty="0">
                 <a:solidFill>
+                  <a:srgbClr val="16A34A"/>
+                </a:solidFill>
+              </a:rPr>
+              <a:t>✅  Insights Positivos</a:t>
+            </a:r>
+            <a:endParaRPr lang="en-US" sz="1300" dirty="0"/>
+          </a:p>
+        </p:txBody>
+      </p:sp>
+      <p:sp>
+        <p:nvSpPr>
+          <p:cNvPr id="14" name="Text 12"/>
+          <p:cNvSpPr/>
+          <p:nvPr/>
+        </p:nvSpPr>
+        <p:spPr>
+          <a:xfrm>
+            <a:off x="457200" y="3017520"/>
+            <a:ext cx="3840480" cy="530352"/>
+          </a:xfrm>
+          <a:prstGeom prst="rect">
+            <a:avLst/>
+          </a:prstGeom>
+          <a:noFill/>
+          <a:ln/>
+        </p:spPr>
+        <p:txBody>
+          <a:bodyPr wrap="square" rtlCol="0" anchor="ctr"/>
+          <a:lstStyle/>
+          <a:p>
+            <a:pPr indent="0" marL="0">
+              <a:buNone/>
+            </a:pPr>
+            <a:r>
+              <a:rPr lang="en-US" sz="1200" dirty="0">
+                <a:solidFill>
+                  <a:srgbClr val="1E293B"/>
+                </a:solidFill>
+              </a:rPr>
+              <a:t>＋  Considera que CheckAuto genera confianza en el proceso de venta</a:t>
+            </a:r>
+            <a:endParaRPr lang="en-US" sz="1200" dirty="0"/>
+          </a:p>
+        </p:txBody>
+      </p:sp>
+      <p:sp>
+        <p:nvSpPr>
+          <p:cNvPr id="15" name="Text 13"/>
+          <p:cNvSpPr/>
+          <p:nvPr/>
+        </p:nvSpPr>
+        <p:spPr>
+          <a:xfrm>
+            <a:off x="457200" y="3611880"/>
+            <a:ext cx="3840480" cy="530352"/>
+          </a:xfrm>
+          <a:prstGeom prst="rect">
+            <a:avLst/>
+          </a:prstGeom>
+          <a:noFill/>
+          <a:ln/>
+        </p:spPr>
+        <p:txBody>
+          <a:bodyPr wrap="square" rtlCol="0" anchor="ctr"/>
+          <a:lstStyle/>
+          <a:p>
+            <a:pPr indent="0" marL="0">
+              <a:buNone/>
+            </a:pPr>
+            <a:r>
+              <a:rPr lang="en-US" sz="1200" dirty="0">
+                <a:solidFill>
+                  <a:srgbClr val="1E293B"/>
+                </a:solidFill>
+              </a:rPr>
+              <a:t>＋  Le parece útil tener un reporte oficial para mostrar al comprador</a:t>
+            </a:r>
+            <a:endParaRPr lang="en-US" sz="1200" dirty="0"/>
+          </a:p>
+        </p:txBody>
+      </p:sp>
+      <p:sp>
+        <p:nvSpPr>
+          <p:cNvPr id="16" name="Text 14"/>
+          <p:cNvSpPr/>
+          <p:nvPr/>
+        </p:nvSpPr>
+        <p:spPr>
+          <a:xfrm>
+            <a:off x="457200" y="4206240"/>
+            <a:ext cx="3840480" cy="530352"/>
+          </a:xfrm>
+          <a:prstGeom prst="rect">
+            <a:avLst/>
+          </a:prstGeom>
+          <a:noFill/>
+          <a:ln/>
+        </p:spPr>
+        <p:txBody>
+          <a:bodyPr wrap="square" rtlCol="0" anchor="ctr"/>
+          <a:lstStyle/>
+          <a:p>
+            <a:pPr indent="0" marL="0">
+              <a:buNone/>
+            </a:pPr>
+            <a:r>
+              <a:rPr lang="en-US" sz="1200" dirty="0">
+                <a:solidFill>
+                  <a:srgbClr val="1E293B"/>
+                </a:solidFill>
+              </a:rPr>
+              <a:t>＋  Cree que acelera el cierre de ventas al eliminar dudas del cliente</a:t>
+            </a:r>
+            <a:endParaRPr lang="en-US" sz="1200" dirty="0"/>
+          </a:p>
+        </p:txBody>
+      </p:sp>
+      <p:sp>
+        <p:nvSpPr>
+          <p:cNvPr id="17" name="Shape 15"/>
+          <p:cNvSpPr/>
+          <p:nvPr/>
+        </p:nvSpPr>
+        <p:spPr>
+          <a:xfrm>
+            <a:off x="4663440" y="2514600"/>
+            <a:ext cx="4206240" cy="2377440"/>
+          </a:xfrm>
+          <a:prstGeom prst="roundRect">
+            <a:avLst>
+              <a:gd name="adj" fmla="val 3846"/>
+            </a:avLst>
+          </a:prstGeom>
+          <a:solidFill>
+            <a:srgbClr val="FFFFFF"/>
+          </a:solidFill>
+          <a:ln w="12700">
+            <a:solidFill>
+              <a:srgbClr val="FEE2E2"/>
+            </a:solidFill>
+            <a:prstDash val="solid"/>
+          </a:ln>
+          <a:effectLst>
+            <a:outerShdw sx="100000" sy="100000" kx="0" ky="0" algn="bl" rotWithShape="0" blurRad="101600" dist="38100" dir="2700000">
+              <a:srgbClr val="000000">
+                <a:alpha val="12000"/>
+              </a:srgbClr>
+            </a:outerShdw>
+          </a:effectLst>
+        </p:spPr>
+      </p:sp>
+      <p:sp>
+        <p:nvSpPr>
+          <p:cNvPr id="18" name="Text 16"/>
+          <p:cNvSpPr/>
+          <p:nvPr/>
+        </p:nvSpPr>
+        <p:spPr>
+          <a:xfrm>
+            <a:off x="4846320" y="2587752"/>
+            <a:ext cx="3840480" cy="384048"/>
+          </a:xfrm>
+          <a:prstGeom prst="rect">
+            <a:avLst/>
+          </a:prstGeom>
+          <a:noFill/>
+          <a:ln/>
+        </p:spPr>
+        <p:txBody>
+          <a:bodyPr wrap="square" lIns="0" tIns="0" rIns="0" bIns="0" rtlCol="0" anchor="ctr"/>
+          <a:lstStyle/>
+          <a:p>
+            <a:pPr indent="0" marL="0">
+              <a:buNone/>
+            </a:pPr>
+            <a:r>
+              <a:rPr lang="en-US" sz="1300" b="1" dirty="0">
+                <a:solidFill>
                   <a:srgbClr val="DC2626"/>
                 </a:solidFill>
               </a:rPr>
-              <a:t>⚠️  Insights Negativos</a:t>
+              <a:t>⚠️  Insights Negativos / Oportunidades</a:t>
             </a:r>
             <a:endParaRPr lang="en-US" sz="1300" dirty="0"/>
           </a:p>
@@ -9078,14 +9114,14 @@
       </p:sp>
       <p:sp>
         <p:nvSpPr>
-          <p:cNvPr id="18" name="Text 16"/>
-          <p:cNvSpPr/>
-          <p:nvPr/>
-        </p:nvSpPr>
-        <p:spPr>
-          <a:xfrm>
-            <a:off x="4937760" y="2788920"/>
-            <a:ext cx="3749040" cy="548640"/>
+          <p:cNvPr id="19" name="Text 17"/>
+          <p:cNvSpPr/>
+          <p:nvPr/>
+        </p:nvSpPr>
+        <p:spPr>
+          <a:xfrm>
+            <a:off x="4846320" y="3017520"/>
+            <a:ext cx="3840480" cy="530352"/>
           </a:xfrm>
           <a:prstGeom prst="rect">
             <a:avLst/>
@@ -9106,7 +9142,7 @@
                   <a:srgbClr val="1E293B"/>
                 </a:solidFill>
               </a:rPr>
-              <a:t>- Teme que un informe negativo afecte sus ventas</a:t>
+              <a:t>－  Preocupa que un informe negativo frene una venta en curso</a:t>
             </a:r>
             <a:endParaRPr lang="en-US" sz="1200" dirty="0"/>
           </a:p>
@@ -9114,14 +9150,14 @@
       </p:sp>
       <p:sp>
         <p:nvSpPr>
-          <p:cNvPr id="19" name="Text 17"/>
-          <p:cNvSpPr/>
-          <p:nvPr/>
-        </p:nvSpPr>
-        <p:spPr>
-          <a:xfrm>
-            <a:off x="4937760" y="3429000"/>
-            <a:ext cx="3749040" cy="548640"/>
+          <p:cNvPr id="20" name="Text 18"/>
+          <p:cNvSpPr/>
+          <p:nvPr/>
+        </p:nvSpPr>
+        <p:spPr>
+          <a:xfrm>
+            <a:off x="4846320" y="3611880"/>
+            <a:ext cx="3840480" cy="530352"/>
           </a:xfrm>
           <a:prstGeom prst="rect">
             <a:avLst/>
@@ -9142,7 +9178,7 @@
                   <a:srgbClr val="1E293B"/>
                 </a:solidFill>
               </a:rPr>
-              <a:t>- Preferiría que el proceso sea rápido (menos de 2 horas)</a:t>
+              <a:t>－  Preferiría que la inspección dure menos de 2 horas</a:t>
             </a:r>
             <a:endParaRPr lang="en-US" sz="1200" dirty="0"/>
           </a:p>
@@ -9150,14 +9186,14 @@
       </p:sp>
       <p:sp>
         <p:nvSpPr>
-          <p:cNvPr id="20" name="Text 18"/>
-          <p:cNvSpPr/>
-          <p:nvPr/>
-        </p:nvSpPr>
-        <p:spPr>
-          <a:xfrm>
-            <a:off x="4937760" y="4069080"/>
-            <a:ext cx="3749040" cy="548640"/>
+          <p:cNvPr id="21" name="Text 19"/>
+          <p:cNvSpPr/>
+          <p:nvPr/>
+        </p:nvSpPr>
+        <p:spPr>
+          <a:xfrm>
+            <a:off x="4846320" y="4206240"/>
+            <a:ext cx="3840480" cy="530352"/>
           </a:xfrm>
           <a:prstGeom prst="rect">
             <a:avLst/>
@@ -9178,7 +9214,7 @@
                   <a:srgbClr val="1E293B"/>
                 </a:solidFill>
               </a:rPr>
-              <a:t>- Duda del precio si el reporte no trae fotos detalladas</a:t>
+              <a:t>－  Quisiera opciones de precio más accesibles para vendedores frecuentes</a:t>
             </a:r>
             <a:endParaRPr lang="en-US" sz="1200" dirty="0"/>
           </a:p>
@@ -9310,18 +9346,20 @@
         </p:nvSpPr>
         <p:spPr>
           <a:xfrm>
-            <a:off x="365760" y="1005840"/>
-            <a:ext cx="2011680" cy="2011680"/>
-          </a:xfrm>
-          <a:prstGeom prst="ellipse">
-            <a:avLst/>
+            <a:off x="320040" y="960120"/>
+            <a:ext cx="2194560" cy="2331720"/>
+          </a:xfrm>
+          <a:prstGeom prst="roundRect">
+            <a:avLst>
+              <a:gd name="adj" fmla="val 6250"/>
+            </a:avLst>
           </a:prstGeom>
           <a:solidFill>
-            <a:srgbClr val="1E4D8C"/>
+            <a:srgbClr val="EBF2FC"/>
           </a:solidFill>
-          <a:ln w="38100">
+          <a:ln w="31750">
             <a:solidFill>
-              <a:srgbClr val="1B3A6B"/>
+              <a:srgbClr val="1E4D8C"/>
             </a:solidFill>
             <a:prstDash val="solid"/>
           </a:ln>
@@ -9342,8 +9380,8 @@
         </p:nvSpPr>
         <p:spPr>
           <a:xfrm>
-            <a:off x="365760" y="1005840"/>
-            <a:ext cx="2011680" cy="2011680"/>
+            <a:off x="320040" y="1417320"/>
+            <a:ext cx="2194560" cy="640080"/>
           </a:xfrm>
           <a:prstGeom prst="rect">
             <a:avLst/>
@@ -9359,14 +9397,14 @@
               <a:buNone/>
             </a:pPr>
             <a:r>
-              <a:rPr lang="en-US" sz="6000" dirty="0">
+              <a:rPr lang="en-US" sz="3200" dirty="0">
                 <a:solidFill>
                   <a:srgbClr val="000000"/>
                 </a:solidFill>
               </a:rPr>
-              <a:t>👤</a:t>
-            </a:r>
-            <a:endParaRPr lang="en-US" sz="6000" dirty="0"/>
+              <a:t>📷</a:t>
+            </a:r>
+            <a:endParaRPr lang="en-US" sz="3200" dirty="0"/>
           </a:p>
         </p:txBody>
       </p:sp>
@@ -9378,105 +9416,8 @@
         </p:nvSpPr>
         <p:spPr>
           <a:xfrm>
-            <a:off x="2560320" y="1051560"/>
-            <a:ext cx="6217920" cy="548640"/>
-          </a:xfrm>
-          <a:prstGeom prst="rect">
-            <a:avLst/>
-          </a:prstGeom>
-          <a:noFill/>
-          <a:ln/>
-        </p:spPr>
-        <p:txBody>
-          <a:bodyPr wrap="square" lIns="0" tIns="0" rIns="0" bIns="0" rtlCol="0" anchor="ctr"/>
-          <a:lstStyle/>
-          <a:p>
-            <a:pPr indent="0" marL="0">
-              <a:buNone/>
-            </a:pPr>
-            <a:r>
-              <a:rPr lang="en-US" sz="2200" b="1" dirty="0">
-                <a:solidFill>
-                  <a:srgbClr val="1B3A6B"/>
-                </a:solidFill>
-              </a:rPr>
-              <a:t>María Fernanda López</a:t>
-            </a:r>
-            <a:endParaRPr lang="en-US" sz="2200" dirty="0"/>
-          </a:p>
-        </p:txBody>
-      </p:sp>
-      <p:sp>
-        <p:nvSpPr>
-          <p:cNvPr id="8" name="Text 6"/>
-          <p:cNvSpPr/>
-          <p:nvPr/>
-        </p:nvSpPr>
-        <p:spPr>
-          <a:xfrm>
-            <a:off x="2560320" y="1600200"/>
-            <a:ext cx="6217920" cy="411480"/>
-          </a:xfrm>
-          <a:prstGeom prst="rect">
-            <a:avLst/>
-          </a:prstGeom>
-          <a:noFill/>
-          <a:ln/>
-        </p:spPr>
-        <p:txBody>
-          <a:bodyPr wrap="square" lIns="0" tIns="0" rIns="0" bIns="0" rtlCol="0" anchor="ctr"/>
-          <a:lstStyle/>
-          <a:p>
-            <a:pPr indent="0" marL="0">
-              <a:buNone/>
-            </a:pPr>
-            <a:r>
-              <a:rPr lang="en-US" sz="1300" dirty="0">
-                <a:solidFill>
-                  <a:srgbClr val="64748B"/>
-                </a:solidFill>
-              </a:rPr>
-              <a:t>28 años  |  Compradora de primer vehículo</a:t>
-            </a:r>
-            <a:endParaRPr lang="en-US" sz="1300" dirty="0"/>
-          </a:p>
-        </p:txBody>
-      </p:sp>
-      <p:sp>
-        <p:nvSpPr>
-          <p:cNvPr id="9" name="Shape 7"/>
-          <p:cNvSpPr/>
-          <p:nvPr/>
-        </p:nvSpPr>
-        <p:spPr>
-          <a:xfrm>
-            <a:off x="2560320" y="2057400"/>
-            <a:ext cx="5943600" cy="36576"/>
-          </a:xfrm>
-          <a:prstGeom prst="rect">
-            <a:avLst/>
-          </a:prstGeom>
-          <a:solidFill>
-            <a:srgbClr val="F97316"/>
-          </a:solidFill>
-          <a:ln w="12700">
-            <a:solidFill>
-              <a:srgbClr val="F97316"/>
-            </a:solidFill>
-            <a:prstDash val="solid"/>
-          </a:ln>
-        </p:spPr>
-      </p:sp>
-      <p:sp>
-        <p:nvSpPr>
-          <p:cNvPr id="10" name="Text 8"/>
-          <p:cNvSpPr/>
-          <p:nvPr/>
-        </p:nvSpPr>
-        <p:spPr>
-          <a:xfrm>
-            <a:off x="365760" y="3063240"/>
-            <a:ext cx="2011680" cy="548640"/>
+            <a:off x="320040" y="2103120"/>
+            <a:ext cx="2194560" cy="640080"/>
           </a:xfrm>
           <a:prstGeom prst="rect">
             <a:avLst/>
@@ -9494,10 +9435,10 @@
             <a:r>
               <a:rPr lang="en-US" sz="1000" i="1" dirty="0">
                 <a:solidFill>
-                  <a:srgbClr val="64748B"/>
-                </a:solidFill>
-              </a:rPr>
-              <a:t>Foto del</a:t>
+                  <a:srgbClr val="1E4D8C"/>
+                </a:solidFill>
+              </a:rPr>
+              <a:t>Insertar foto</a:t>
             </a:r>
             <a:endParaRPr lang="en-US" sz="1000" dirty="0"/>
           </a:p>
@@ -9508,10 +9449,10 @@
             <a:r>
               <a:rPr lang="en-US" sz="1000" i="1" dirty="0">
                 <a:solidFill>
-                  <a:srgbClr val="64748B"/>
-                </a:solidFill>
-              </a:rPr>
-              <a:t>Entrevistado</a:t>
+                  <a:srgbClr val="1E4D8C"/>
+                </a:solidFill>
+              </a:rPr>
+              <a:t>del entrevistado</a:t>
             </a:r>
             <a:endParaRPr lang="en-US" sz="1000" dirty="0"/>
           </a:p>
@@ -9519,18 +9460,18 @@
       </p:sp>
       <p:sp>
         <p:nvSpPr>
-          <p:cNvPr id="11" name="Shape 9"/>
-          <p:cNvSpPr/>
-          <p:nvPr/>
-        </p:nvSpPr>
-        <p:spPr>
-          <a:xfrm>
-            <a:off x="274320" y="2240280"/>
-            <a:ext cx="4114800" cy="2606040"/>
+          <p:cNvPr id="8" name="Shape 6"/>
+          <p:cNvSpPr/>
+          <p:nvPr/>
+        </p:nvSpPr>
+        <p:spPr>
+          <a:xfrm>
+            <a:off x="2697480" y="960120"/>
+            <a:ext cx="6126480" cy="1371600"/>
           </a:xfrm>
           <a:prstGeom prst="roundRect">
             <a:avLst>
-              <a:gd name="adj" fmla="val 3509"/>
+              <a:gd name="adj" fmla="val 6667"/>
             </a:avLst>
           </a:prstGeom>
           <a:solidFill>
@@ -9553,14 +9494,14 @@
       </p:sp>
       <p:sp>
         <p:nvSpPr>
-          <p:cNvPr id="12" name="Text 10"/>
-          <p:cNvSpPr/>
-          <p:nvPr/>
-        </p:nvSpPr>
-        <p:spPr>
-          <a:xfrm>
-            <a:off x="457200" y="2331720"/>
-            <a:ext cx="3749040" cy="411480"/>
+          <p:cNvPr id="9" name="Text 7"/>
+          <p:cNvSpPr/>
+          <p:nvPr/>
+        </p:nvSpPr>
+        <p:spPr>
+          <a:xfrm>
+            <a:off x="2834640" y="1005840"/>
+            <a:ext cx="5852160" cy="594360"/>
           </a:xfrm>
           <a:prstGeom prst="rect">
             <a:avLst/>
@@ -9576,12 +9517,73 @@
               <a:buNone/>
             </a:pPr>
             <a:r>
-              <a:rPr lang="en-US" sz="1300" b="1" dirty="0">
-                <a:solidFill>
-                  <a:srgbClr val="16A34A"/>
-                </a:solidFill>
-              </a:rPr>
-              <a:t>✅  Insights Positivos</a:t>
+              <a:rPr lang="en-US" sz="2600" b="1" dirty="0">
+                <a:solidFill>
+                  <a:srgbClr val="1B3A6B"/>
+                </a:solidFill>
+              </a:rPr>
+              <a:t>Luana</a:t>
+            </a:r>
+            <a:endParaRPr lang="en-US" sz="2600" dirty="0"/>
+          </a:p>
+        </p:txBody>
+      </p:sp>
+      <p:sp>
+        <p:nvSpPr>
+          <p:cNvPr id="10" name="Shape 8"/>
+          <p:cNvSpPr/>
+          <p:nvPr/>
+        </p:nvSpPr>
+        <p:spPr>
+          <a:xfrm>
+            <a:off x="2834640" y="1627632"/>
+            <a:ext cx="1097280" cy="36576"/>
+          </a:xfrm>
+          <a:prstGeom prst="rect">
+            <a:avLst/>
+          </a:prstGeom>
+          <a:solidFill>
+            <a:srgbClr val="F97316"/>
+          </a:solidFill>
+          <a:ln w="12700">
+            <a:solidFill>
+              <a:srgbClr val="F97316"/>
+            </a:solidFill>
+            <a:prstDash val="solid"/>
+          </a:ln>
+        </p:spPr>
+      </p:sp>
+      <p:sp>
+        <p:nvSpPr>
+          <p:cNvPr id="11" name="Text 9"/>
+          <p:cNvSpPr/>
+          <p:nvPr/>
+        </p:nvSpPr>
+        <p:spPr>
+          <a:xfrm>
+            <a:off x="2834640" y="1691640"/>
+            <a:ext cx="5852160" cy="502920"/>
+          </a:xfrm>
+          <a:prstGeom prst="rect">
+            <a:avLst/>
+          </a:prstGeom>
+          <a:noFill/>
+          <a:ln/>
+        </p:spPr>
+        <p:txBody>
+          <a:bodyPr wrap="square" lIns="0" tIns="0" rIns="0" bIns="0" rtlCol="0" anchor="ctr"/>
+          <a:lstStyle/>
+          <a:p>
+            <a:pPr indent="0" marL="0">
+              <a:buNone/>
+            </a:pPr>
+            <a:r>
+              <a:rPr lang="en-US" sz="1300" i="1" dirty="0">
+                <a:solidFill>
+                  <a:srgbClr val="64748B"/>
+                </a:solidFill>
+              </a:rPr>
+              <a:t>23 años  ·  Diseñadora UX/UI</a:t>
             </a:r>
             <a:endParaRPr lang="en-US" sz="1300" dirty="0"/>
           </a:p>
@@ -9589,126 +9591,18 @@
       </p:sp>
       <p:sp>
         <p:nvSpPr>
-          <p:cNvPr id="13" name="Text 11"/>
-          <p:cNvSpPr/>
-          <p:nvPr/>
-        </p:nvSpPr>
-        <p:spPr>
-          <a:xfrm>
-            <a:off x="457200" y="2788920"/>
-            <a:ext cx="3749040" cy="548640"/>
-          </a:xfrm>
-          <a:prstGeom prst="rect">
-            <a:avLst/>
-          </a:prstGeom>
-          <a:noFill/>
-          <a:ln/>
-        </p:spPr>
-        <p:txBody>
-          <a:bodyPr wrap="square" rtlCol="0" anchor="ctr"/>
-          <a:lstStyle/>
-          <a:p>
-            <a:pPr indent="0" marL="0">
-              <a:buNone/>
-            </a:pPr>
-            <a:r>
-              <a:rPr lang="en-US" sz="1200" dirty="0">
-                <a:solidFill>
-                  <a:srgbClr val="1E293B"/>
-                </a:solidFill>
-              </a:rPr>
-              <a:t>+ Le da mucha seguridad saber que el auto fue revisado</a:t>
-            </a:r>
-            <a:endParaRPr lang="en-US" sz="1200" dirty="0"/>
-          </a:p>
-        </p:txBody>
-      </p:sp>
-      <p:sp>
-        <p:nvSpPr>
-          <p:cNvPr id="14" name="Text 12"/>
-          <p:cNvSpPr/>
-          <p:nvPr/>
-        </p:nvSpPr>
-        <p:spPr>
-          <a:xfrm>
-            <a:off x="457200" y="3429000"/>
-            <a:ext cx="3749040" cy="548640"/>
-          </a:xfrm>
-          <a:prstGeom prst="rect">
-            <a:avLst/>
-          </a:prstGeom>
-          <a:noFill/>
-          <a:ln/>
-        </p:spPr>
-        <p:txBody>
-          <a:bodyPr wrap="square" rtlCol="0" anchor="ctr"/>
-          <a:lstStyle/>
-          <a:p>
-            <a:pPr indent="0" marL="0">
-              <a:buNone/>
-            </a:pPr>
-            <a:r>
-              <a:rPr lang="en-US" sz="1200" dirty="0">
-                <a:solidFill>
-                  <a:srgbClr val="1E293B"/>
-                </a:solidFill>
-              </a:rPr>
-              <a:t>+ Valora el reporte digital accesible desde su celular</a:t>
-            </a:r>
-            <a:endParaRPr lang="en-US" sz="1200" dirty="0"/>
-          </a:p>
-        </p:txBody>
-      </p:sp>
-      <p:sp>
-        <p:nvSpPr>
-          <p:cNvPr id="15" name="Text 13"/>
-          <p:cNvSpPr/>
-          <p:nvPr/>
-        </p:nvSpPr>
-        <p:spPr>
-          <a:xfrm>
-            <a:off x="457200" y="4069080"/>
-            <a:ext cx="3749040" cy="548640"/>
-          </a:xfrm>
-          <a:prstGeom prst="rect">
-            <a:avLst/>
-          </a:prstGeom>
-          <a:noFill/>
-          <a:ln/>
-        </p:spPr>
-        <p:txBody>
-          <a:bodyPr wrap="square" rtlCol="0" anchor="ctr"/>
-          <a:lstStyle/>
-          <a:p>
-            <a:pPr indent="0" marL="0">
-              <a:buNone/>
-            </a:pPr>
-            <a:r>
-              <a:rPr lang="en-US" sz="1200" dirty="0">
-                <a:solidFill>
-                  <a:srgbClr val="1E293B"/>
-                </a:solidFill>
-              </a:rPr>
-              <a:t>+ Le gusta la opción de inspección a domicilio</a:t>
-            </a:r>
-            <a:endParaRPr lang="en-US" sz="1200" dirty="0"/>
-          </a:p>
-        </p:txBody>
-      </p:sp>
-      <p:sp>
-        <p:nvSpPr>
-          <p:cNvPr id="16" name="Shape 14"/>
-          <p:cNvSpPr/>
-          <p:nvPr/>
-        </p:nvSpPr>
-        <p:spPr>
-          <a:xfrm>
-            <a:off x="4754880" y="2240280"/>
-            <a:ext cx="4114800" cy="2606040"/>
+          <p:cNvPr id="12" name="Shape 10"/>
+          <p:cNvSpPr/>
+          <p:nvPr/>
+        </p:nvSpPr>
+        <p:spPr>
+          <a:xfrm>
+            <a:off x="274320" y="2514600"/>
+            <a:ext cx="4206240" cy="2377440"/>
           </a:xfrm>
           <a:prstGeom prst="roundRect">
             <a:avLst>
-              <a:gd name="adj" fmla="val 3509"/>
+              <a:gd name="adj" fmla="val 3846"/>
             </a:avLst>
           </a:prstGeom>
           <a:solidFill>
@@ -9716,7 +9610,7 @@
           </a:solidFill>
           <a:ln w="12700">
             <a:solidFill>
-              <a:srgbClr val="DCE8F5"/>
+              <a:srgbClr val="D1FAE5"/>
             </a:solidFill>
             <a:prstDash val="solid"/>
           </a:ln>
@@ -9731,14 +9625,14 @@
       </p:sp>
       <p:sp>
         <p:nvSpPr>
-          <p:cNvPr id="17" name="Text 15"/>
-          <p:cNvSpPr/>
-          <p:nvPr/>
-        </p:nvSpPr>
-        <p:spPr>
-          <a:xfrm>
-            <a:off x="4937760" y="2331720"/>
-            <a:ext cx="3749040" cy="411480"/>
+          <p:cNvPr id="13" name="Text 11"/>
+          <p:cNvSpPr/>
+          <p:nvPr/>
+        </p:nvSpPr>
+        <p:spPr>
+          <a:xfrm>
+            <a:off x="457200" y="2587752"/>
+            <a:ext cx="3840480" cy="384048"/>
           </a:xfrm>
           <a:prstGeom prst="rect">
             <a:avLst/>
@@ -9756,10 +9650,188 @@
             <a:r>
               <a:rPr lang="en-US" sz="1300" b="1" dirty="0">
                 <a:solidFill>
+                  <a:srgbClr val="16A34A"/>
+                </a:solidFill>
+              </a:rPr>
+              <a:t>✅  Insights Positivos</a:t>
+            </a:r>
+            <a:endParaRPr lang="en-US" sz="1300" dirty="0"/>
+          </a:p>
+        </p:txBody>
+      </p:sp>
+      <p:sp>
+        <p:nvSpPr>
+          <p:cNvPr id="14" name="Text 12"/>
+          <p:cNvSpPr/>
+          <p:nvPr/>
+        </p:nvSpPr>
+        <p:spPr>
+          <a:xfrm>
+            <a:off x="457200" y="3017520"/>
+            <a:ext cx="3840480" cy="530352"/>
+          </a:xfrm>
+          <a:prstGeom prst="rect">
+            <a:avLst/>
+          </a:prstGeom>
+          <a:noFill/>
+          <a:ln/>
+        </p:spPr>
+        <p:txBody>
+          <a:bodyPr wrap="square" rtlCol="0" anchor="ctr"/>
+          <a:lstStyle/>
+          <a:p>
+            <a:pPr indent="0" marL="0">
+              <a:buNone/>
+            </a:pPr>
+            <a:r>
+              <a:rPr lang="en-US" sz="1200" dirty="0">
+                <a:solidFill>
+                  <a:srgbClr val="1E293B"/>
+                </a:solidFill>
+              </a:rPr>
+              <a:t>＋  Valora muchísimo la transparencia visual del reporte digital</a:t>
+            </a:r>
+            <a:endParaRPr lang="en-US" sz="1200" dirty="0"/>
+          </a:p>
+        </p:txBody>
+      </p:sp>
+      <p:sp>
+        <p:nvSpPr>
+          <p:cNvPr id="15" name="Text 13"/>
+          <p:cNvSpPr/>
+          <p:nvPr/>
+        </p:nvSpPr>
+        <p:spPr>
+          <a:xfrm>
+            <a:off x="457200" y="3611880"/>
+            <a:ext cx="3840480" cy="530352"/>
+          </a:xfrm>
+          <a:prstGeom prst="rect">
+            <a:avLst/>
+          </a:prstGeom>
+          <a:noFill/>
+          <a:ln/>
+        </p:spPr>
+        <p:txBody>
+          <a:bodyPr wrap="square" rtlCol="0" anchor="ctr"/>
+          <a:lstStyle/>
+          <a:p>
+            <a:pPr indent="0" marL="0">
+              <a:buNone/>
+            </a:pPr>
+            <a:r>
+              <a:rPr lang="en-US" sz="1200" dirty="0">
+                <a:solidFill>
+                  <a:srgbClr val="1E293B"/>
+                </a:solidFill>
+              </a:rPr>
+              <a:t>＋  Le parece intuitiva la idea de agendar desde la app o web</a:t>
+            </a:r>
+            <a:endParaRPr lang="en-US" sz="1200" dirty="0"/>
+          </a:p>
+        </p:txBody>
+      </p:sp>
+      <p:sp>
+        <p:nvSpPr>
+          <p:cNvPr id="16" name="Text 14"/>
+          <p:cNvSpPr/>
+          <p:nvPr/>
+        </p:nvSpPr>
+        <p:spPr>
+          <a:xfrm>
+            <a:off x="457200" y="4206240"/>
+            <a:ext cx="3840480" cy="530352"/>
+          </a:xfrm>
+          <a:prstGeom prst="rect">
+            <a:avLst/>
+          </a:prstGeom>
+          <a:noFill/>
+          <a:ln/>
+        </p:spPr>
+        <p:txBody>
+          <a:bodyPr wrap="square" rtlCol="0" anchor="ctr"/>
+          <a:lstStyle/>
+          <a:p>
+            <a:pPr indent="0" marL="0">
+              <a:buNone/>
+            </a:pPr>
+            <a:r>
+              <a:rPr lang="en-US" sz="1200" dirty="0">
+                <a:solidFill>
+                  <a:srgbClr val="1E293B"/>
+                </a:solidFill>
+              </a:rPr>
+              <a:t>＋  Destaca la importancia de una experiencia de usuario clara y confiable</a:t>
+            </a:r>
+            <a:endParaRPr lang="en-US" sz="1200" dirty="0"/>
+          </a:p>
+        </p:txBody>
+      </p:sp>
+      <p:sp>
+        <p:nvSpPr>
+          <p:cNvPr id="17" name="Shape 15"/>
+          <p:cNvSpPr/>
+          <p:nvPr/>
+        </p:nvSpPr>
+        <p:spPr>
+          <a:xfrm>
+            <a:off x="4663440" y="2514600"/>
+            <a:ext cx="4206240" cy="2377440"/>
+          </a:xfrm>
+          <a:prstGeom prst="roundRect">
+            <a:avLst>
+              <a:gd name="adj" fmla="val 3846"/>
+            </a:avLst>
+          </a:prstGeom>
+          <a:solidFill>
+            <a:srgbClr val="FFFFFF"/>
+          </a:solidFill>
+          <a:ln w="12700">
+            <a:solidFill>
+              <a:srgbClr val="FEE2E2"/>
+            </a:solidFill>
+            <a:prstDash val="solid"/>
+          </a:ln>
+          <a:effectLst>
+            <a:outerShdw sx="100000" sy="100000" kx="0" ky="0" algn="bl" rotWithShape="0" blurRad="101600" dist="38100" dir="2700000">
+              <a:srgbClr val="000000">
+                <a:alpha val="12000"/>
+              </a:srgbClr>
+            </a:outerShdw>
+          </a:effectLst>
+        </p:spPr>
+      </p:sp>
+      <p:sp>
+        <p:nvSpPr>
+          <p:cNvPr id="18" name="Text 16"/>
+          <p:cNvSpPr/>
+          <p:nvPr/>
+        </p:nvSpPr>
+        <p:spPr>
+          <a:xfrm>
+            <a:off x="4846320" y="2587752"/>
+            <a:ext cx="3840480" cy="384048"/>
+          </a:xfrm>
+          <a:prstGeom prst="rect">
+            <a:avLst/>
+          </a:prstGeom>
+          <a:noFill/>
+          <a:ln/>
+        </p:spPr>
+        <p:txBody>
+          <a:bodyPr wrap="square" lIns="0" tIns="0" rIns="0" bIns="0" rtlCol="0" anchor="ctr"/>
+          <a:lstStyle/>
+          <a:p>
+            <a:pPr indent="0" marL="0">
+              <a:buNone/>
+            </a:pPr>
+            <a:r>
+              <a:rPr lang="en-US" sz="1300" b="1" dirty="0">
+                <a:solidFill>
                   <a:srgbClr val="DC2626"/>
                 </a:solidFill>
               </a:rPr>
-              <a:t>⚠️  Insights Negativos</a:t>
+              <a:t>⚠️  Insights Negativos / Oportunidades</a:t>
             </a:r>
             <a:endParaRPr lang="en-US" sz="1300" dirty="0"/>
           </a:p>
@@ -9767,14 +9839,14 @@
       </p:sp>
       <p:sp>
         <p:nvSpPr>
-          <p:cNvPr id="18" name="Text 16"/>
-          <p:cNvSpPr/>
-          <p:nvPr/>
-        </p:nvSpPr>
-        <p:spPr>
-          <a:xfrm>
-            <a:off x="4937760" y="2788920"/>
-            <a:ext cx="3749040" cy="548640"/>
+          <p:cNvPr id="19" name="Text 17"/>
+          <p:cNvSpPr/>
+          <p:nvPr/>
+        </p:nvSpPr>
+        <p:spPr>
+          <a:xfrm>
+            <a:off x="4846320" y="3017520"/>
+            <a:ext cx="3840480" cy="530352"/>
           </a:xfrm>
           <a:prstGeom prst="rect">
             <a:avLst/>
@@ -9795,7 +9867,7 @@
                   <a:srgbClr val="1E293B"/>
                 </a:solidFill>
               </a:rPr>
-              <a:t>- No conocía ningún servicio similar antes</a:t>
+              <a:t>－  Considera que la interfaz actual necesita mayor claridad visual</a:t>
             </a:r>
             <a:endParaRPr lang="en-US" sz="1200" dirty="0"/>
           </a:p>
@@ -9803,14 +9875,14 @@
       </p:sp>
       <p:sp>
         <p:nvSpPr>
-          <p:cNvPr id="19" name="Text 17"/>
-          <p:cNvSpPr/>
-          <p:nvPr/>
-        </p:nvSpPr>
-        <p:spPr>
-          <a:xfrm>
-            <a:off x="4937760" y="3429000"/>
-            <a:ext cx="3749040" cy="548640"/>
+          <p:cNvPr id="20" name="Text 18"/>
+          <p:cNvSpPr/>
+          <p:nvPr/>
+        </p:nvSpPr>
+        <p:spPr>
+          <a:xfrm>
+            <a:off x="4846320" y="3611880"/>
+            <a:ext cx="3840480" cy="530352"/>
           </a:xfrm>
           <a:prstGeom prst="rect">
             <a:avLst/>
@@ -9831,7 +9903,7 @@
                   <a:srgbClr val="1E293B"/>
                 </a:solidFill>
               </a:rPr>
-              <a:t>- Le gustaría un plan más económico para estudiantes</a:t>
+              <a:t>－  Sugiere mejorar el flujo de onboarding para nuevos usuarios</a:t>
             </a:r>
             <a:endParaRPr lang="en-US" sz="1200" dirty="0"/>
           </a:p>
@@ -9839,14 +9911,14 @@
       </p:sp>
       <p:sp>
         <p:nvSpPr>
-          <p:cNvPr id="20" name="Text 18"/>
-          <p:cNvSpPr/>
-          <p:nvPr/>
-        </p:nvSpPr>
-        <p:spPr>
-          <a:xfrm>
-            <a:off x="4937760" y="4069080"/>
-            <a:ext cx="3749040" cy="548640"/>
+          <p:cNvPr id="21" name="Text 19"/>
+          <p:cNvSpPr/>
+          <p:nvPr/>
+        </p:nvSpPr>
+        <p:spPr>
+          <a:xfrm>
+            <a:off x="4846320" y="4206240"/>
+            <a:ext cx="3840480" cy="530352"/>
           </a:xfrm>
           <a:prstGeom prst="rect">
             <a:avLst/>
@@ -9867,7 +9939,7 @@
                   <a:srgbClr val="1E293B"/>
                 </a:solidFill>
               </a:rPr>
-              <a:t>- Preferiría pagar en cuotas</a:t>
+              <a:t>－  Le gustaría que el reporte tenga más elementos visuales e íconos</a:t>
             </a:r>
             <a:endParaRPr lang="en-US" sz="1200" dirty="0"/>
           </a:p>
@@ -10618,18 +10690,20 @@
         </p:nvSpPr>
         <p:spPr>
           <a:xfrm>
-            <a:off x="365760" y="1005840"/>
-            <a:ext cx="2011680" cy="2011680"/>
-          </a:xfrm>
-          <a:prstGeom prst="ellipse">
-            <a:avLst/>
+            <a:off x="320040" y="960120"/>
+            <a:ext cx="2194560" cy="2331720"/>
+          </a:xfrm>
+          <a:prstGeom prst="roundRect">
+            <a:avLst>
+              <a:gd name="adj" fmla="val 6250"/>
+            </a:avLst>
           </a:prstGeom>
           <a:solidFill>
-            <a:srgbClr val="1E4D8C"/>
+            <a:srgbClr val="EBF2FC"/>
           </a:solidFill>
-          <a:ln w="38100">
+          <a:ln w="31750">
             <a:solidFill>
-              <a:srgbClr val="1B3A6B"/>
+              <a:srgbClr val="1E4D8C"/>
             </a:solidFill>
             <a:prstDash val="solid"/>
           </a:ln>
@@ -10650,8 +10724,8 @@
         </p:nvSpPr>
         <p:spPr>
           <a:xfrm>
-            <a:off x="365760" y="1005840"/>
-            <a:ext cx="2011680" cy="2011680"/>
+            <a:off x="320040" y="1417320"/>
+            <a:ext cx="2194560" cy="640080"/>
           </a:xfrm>
           <a:prstGeom prst="rect">
             <a:avLst/>
@@ -10667,14 +10741,14 @@
               <a:buNone/>
             </a:pPr>
             <a:r>
-              <a:rPr lang="en-US" sz="6000" dirty="0">
+              <a:rPr lang="en-US" sz="3200" dirty="0">
                 <a:solidFill>
                   <a:srgbClr val="000000"/>
                 </a:solidFill>
               </a:rPr>
-              <a:t>👤</a:t>
-            </a:r>
-            <a:endParaRPr lang="en-US" sz="6000" dirty="0"/>
+              <a:t>📷</a:t>
+            </a:r>
+            <a:endParaRPr lang="en-US" sz="3200" dirty="0"/>
           </a:p>
         </p:txBody>
       </p:sp>
@@ -10686,105 +10760,8 @@
         </p:nvSpPr>
         <p:spPr>
           <a:xfrm>
-            <a:off x="2560320" y="1051560"/>
-            <a:ext cx="6217920" cy="548640"/>
-          </a:xfrm>
-          <a:prstGeom prst="rect">
-            <a:avLst/>
-          </a:prstGeom>
-          <a:noFill/>
-          <a:ln/>
-        </p:spPr>
-        <p:txBody>
-          <a:bodyPr wrap="square" lIns="0" tIns="0" rIns="0" bIns="0" rtlCol="0" anchor="ctr"/>
-          <a:lstStyle/>
-          <a:p>
-            <a:pPr indent="0" marL="0">
-              <a:buNone/>
-            </a:pPr>
-            <a:r>
-              <a:rPr lang="en-US" sz="2200" b="1" dirty="0">
-                <a:solidFill>
-                  <a:srgbClr val="1B3A6B"/>
-                </a:solidFill>
-              </a:rPr>
-              <a:t>Roberto Jiménez</a:t>
-            </a:r>
-            <a:endParaRPr lang="en-US" sz="2200" dirty="0"/>
-          </a:p>
-        </p:txBody>
-      </p:sp>
-      <p:sp>
-        <p:nvSpPr>
-          <p:cNvPr id="8" name="Text 6"/>
-          <p:cNvSpPr/>
-          <p:nvPr/>
-        </p:nvSpPr>
-        <p:spPr>
-          <a:xfrm>
-            <a:off x="2560320" y="1600200"/>
-            <a:ext cx="6217920" cy="411480"/>
-          </a:xfrm>
-          <a:prstGeom prst="rect">
-            <a:avLst/>
-          </a:prstGeom>
-          <a:noFill/>
-          <a:ln/>
-        </p:spPr>
-        <p:txBody>
-          <a:bodyPr wrap="square" lIns="0" tIns="0" rIns="0" bIns="0" rtlCol="0" anchor="ctr"/>
-          <a:lstStyle/>
-          <a:p>
-            <a:pPr indent="0" marL="0">
-              <a:buNone/>
-            </a:pPr>
-            <a:r>
-              <a:rPr lang="en-US" sz="1300" dirty="0">
-                <a:solidFill>
-                  <a:srgbClr val="64748B"/>
-                </a:solidFill>
-              </a:rPr>
-              <a:t>45 años  |  Propietario de taller mecánico</a:t>
-            </a:r>
-            <a:endParaRPr lang="en-US" sz="1300" dirty="0"/>
-          </a:p>
-        </p:txBody>
-      </p:sp>
-      <p:sp>
-        <p:nvSpPr>
-          <p:cNvPr id="9" name="Shape 7"/>
-          <p:cNvSpPr/>
-          <p:nvPr/>
-        </p:nvSpPr>
-        <p:spPr>
-          <a:xfrm>
-            <a:off x="2560320" y="2057400"/>
-            <a:ext cx="5943600" cy="36576"/>
-          </a:xfrm>
-          <a:prstGeom prst="rect">
-            <a:avLst/>
-          </a:prstGeom>
-          <a:solidFill>
-            <a:srgbClr val="F97316"/>
-          </a:solidFill>
-          <a:ln w="12700">
-            <a:solidFill>
-              <a:srgbClr val="F97316"/>
-            </a:solidFill>
-            <a:prstDash val="solid"/>
-          </a:ln>
-        </p:spPr>
-      </p:sp>
-      <p:sp>
-        <p:nvSpPr>
-          <p:cNvPr id="10" name="Text 8"/>
-          <p:cNvSpPr/>
-          <p:nvPr/>
-        </p:nvSpPr>
-        <p:spPr>
-          <a:xfrm>
-            <a:off x="365760" y="3063240"/>
-            <a:ext cx="2011680" cy="548640"/>
+            <a:off x="320040" y="2103120"/>
+            <a:ext cx="2194560" cy="640080"/>
           </a:xfrm>
           <a:prstGeom prst="rect">
             <a:avLst/>
@@ -10802,10 +10779,10 @@
             <a:r>
               <a:rPr lang="en-US" sz="1000" i="1" dirty="0">
                 <a:solidFill>
-                  <a:srgbClr val="64748B"/>
-                </a:solidFill>
-              </a:rPr>
-              <a:t>Foto del</a:t>
+                  <a:srgbClr val="1E4D8C"/>
+                </a:solidFill>
+              </a:rPr>
+              <a:t>Insertar foto</a:t>
             </a:r>
             <a:endParaRPr lang="en-US" sz="1000" dirty="0"/>
           </a:p>
@@ -10816,10 +10793,10 @@
             <a:r>
               <a:rPr lang="en-US" sz="1000" i="1" dirty="0">
                 <a:solidFill>
-                  <a:srgbClr val="64748B"/>
-                </a:solidFill>
-              </a:rPr>
-              <a:t>Entrevistado</a:t>
+                  <a:srgbClr val="1E4D8C"/>
+                </a:solidFill>
+              </a:rPr>
+              <a:t>del entrevistado</a:t>
             </a:r>
             <a:endParaRPr lang="en-US" sz="1000" dirty="0"/>
           </a:p>
@@ -10827,18 +10804,18 @@
       </p:sp>
       <p:sp>
         <p:nvSpPr>
-          <p:cNvPr id="11" name="Shape 9"/>
-          <p:cNvSpPr/>
-          <p:nvPr/>
-        </p:nvSpPr>
-        <p:spPr>
-          <a:xfrm>
-            <a:off x="274320" y="2240280"/>
-            <a:ext cx="4114800" cy="2606040"/>
+          <p:cNvPr id="8" name="Shape 6"/>
+          <p:cNvSpPr/>
+          <p:nvPr/>
+        </p:nvSpPr>
+        <p:spPr>
+          <a:xfrm>
+            <a:off x="2697480" y="960120"/>
+            <a:ext cx="6126480" cy="1371600"/>
           </a:xfrm>
           <a:prstGeom prst="roundRect">
             <a:avLst>
-              <a:gd name="adj" fmla="val 3509"/>
+              <a:gd name="adj" fmla="val 6667"/>
             </a:avLst>
           </a:prstGeom>
           <a:solidFill>
@@ -10861,14 +10838,14 @@
       </p:sp>
       <p:sp>
         <p:nvSpPr>
-          <p:cNvPr id="12" name="Text 10"/>
-          <p:cNvSpPr/>
-          <p:nvPr/>
-        </p:nvSpPr>
-        <p:spPr>
-          <a:xfrm>
-            <a:off x="457200" y="2331720"/>
-            <a:ext cx="3749040" cy="411480"/>
+          <p:cNvPr id="9" name="Text 7"/>
+          <p:cNvSpPr/>
+          <p:nvPr/>
+        </p:nvSpPr>
+        <p:spPr>
+          <a:xfrm>
+            <a:off x="2834640" y="1005840"/>
+            <a:ext cx="5852160" cy="594360"/>
           </a:xfrm>
           <a:prstGeom prst="rect">
             <a:avLst/>
@@ -10884,12 +10861,73 @@
               <a:buNone/>
             </a:pPr>
             <a:r>
-              <a:rPr lang="en-US" sz="1300" b="1" dirty="0">
-                <a:solidFill>
-                  <a:srgbClr val="16A34A"/>
-                </a:solidFill>
-              </a:rPr>
-              <a:t>✅  Insights Positivos</a:t>
+              <a:rPr lang="en-US" sz="2600" b="1" dirty="0">
+                <a:solidFill>
+                  <a:srgbClr val="1B3A6B"/>
+                </a:solidFill>
+              </a:rPr>
+              <a:t>Participante Focus Group</a:t>
+            </a:r>
+            <a:endParaRPr lang="en-US" sz="2600" dirty="0"/>
+          </a:p>
+        </p:txBody>
+      </p:sp>
+      <p:sp>
+        <p:nvSpPr>
+          <p:cNvPr id="10" name="Shape 8"/>
+          <p:cNvSpPr/>
+          <p:nvPr/>
+        </p:nvSpPr>
+        <p:spPr>
+          <a:xfrm>
+            <a:off x="2834640" y="1627632"/>
+            <a:ext cx="1097280" cy="36576"/>
+          </a:xfrm>
+          <a:prstGeom prst="rect">
+            <a:avLst/>
+          </a:prstGeom>
+          <a:solidFill>
+            <a:srgbClr val="F97316"/>
+          </a:solidFill>
+          <a:ln w="12700">
+            <a:solidFill>
+              <a:srgbClr val="F97316"/>
+            </a:solidFill>
+            <a:prstDash val="solid"/>
+          </a:ln>
+        </p:spPr>
+      </p:sp>
+      <p:sp>
+        <p:nvSpPr>
+          <p:cNvPr id="11" name="Text 9"/>
+          <p:cNvSpPr/>
+          <p:nvPr/>
+        </p:nvSpPr>
+        <p:spPr>
+          <a:xfrm>
+            <a:off x="2834640" y="1691640"/>
+            <a:ext cx="5852160" cy="502920"/>
+          </a:xfrm>
+          <a:prstGeom prst="rect">
+            <a:avLst/>
+          </a:prstGeom>
+          <a:noFill/>
+          <a:ln/>
+        </p:spPr>
+        <p:txBody>
+          <a:bodyPr wrap="square" lIns="0" tIns="0" rIns="0" bIns="0" rtlCol="0" anchor="ctr"/>
+          <a:lstStyle/>
+          <a:p>
+            <a:pPr indent="0" marL="0">
+              <a:buNone/>
+            </a:pPr>
+            <a:r>
+              <a:rPr lang="en-US" sz="1300" i="1" dirty="0">
+                <a:solidFill>
+                  <a:srgbClr val="64748B"/>
+                </a:solidFill>
+              </a:rPr>
+              <a:t>Grupo mixto  ·  Compradores y vendedores de vehículos</a:t>
             </a:r>
             <a:endParaRPr lang="en-US" sz="1300" dirty="0"/>
           </a:p>
@@ -10897,126 +10935,18 @@
       </p:sp>
       <p:sp>
         <p:nvSpPr>
-          <p:cNvPr id="13" name="Text 11"/>
-          <p:cNvSpPr/>
-          <p:nvPr/>
-        </p:nvSpPr>
-        <p:spPr>
-          <a:xfrm>
-            <a:off x="457200" y="2788920"/>
-            <a:ext cx="3749040" cy="548640"/>
-          </a:xfrm>
-          <a:prstGeom prst="rect">
-            <a:avLst/>
-          </a:prstGeom>
-          <a:noFill/>
-          <a:ln/>
-        </p:spPr>
-        <p:txBody>
-          <a:bodyPr wrap="square" rtlCol="0" anchor="ctr"/>
-          <a:lstStyle/>
-          <a:p>
-            <a:pPr indent="0" marL="0">
-              <a:buNone/>
-            </a:pPr>
-            <a:r>
-              <a:rPr lang="en-US" sz="1200" dirty="0">
-                <a:solidFill>
-                  <a:srgbClr val="1E293B"/>
-                </a:solidFill>
-              </a:rPr>
-              <a:t>+ Ve oportunidad de aliarse como taller certificado CheckAuto</a:t>
-            </a:r>
-            <a:endParaRPr lang="en-US" sz="1200" dirty="0"/>
-          </a:p>
-        </p:txBody>
-      </p:sp>
-      <p:sp>
-        <p:nvSpPr>
-          <p:cNvPr id="14" name="Text 12"/>
-          <p:cNvSpPr/>
-          <p:nvPr/>
-        </p:nvSpPr>
-        <p:spPr>
-          <a:xfrm>
-            <a:off x="457200" y="3429000"/>
-            <a:ext cx="3749040" cy="548640"/>
-          </a:xfrm>
-          <a:prstGeom prst="rect">
-            <a:avLst/>
-          </a:prstGeom>
-          <a:noFill/>
-          <a:ln/>
-        </p:spPr>
-        <p:txBody>
-          <a:bodyPr wrap="square" rtlCol="0" anchor="ctr"/>
-          <a:lstStyle/>
-          <a:p>
-            <a:pPr indent="0" marL="0">
-              <a:buNone/>
-            </a:pPr>
-            <a:r>
-              <a:rPr lang="en-US" sz="1200" dirty="0">
-                <a:solidFill>
-                  <a:srgbClr val="1E293B"/>
-                </a:solidFill>
-              </a:rPr>
-              <a:t>+ Apoya la estandarización de los diagnósticos</a:t>
-            </a:r>
-            <a:endParaRPr lang="en-US" sz="1200" dirty="0"/>
-          </a:p>
-        </p:txBody>
-      </p:sp>
-      <p:sp>
-        <p:nvSpPr>
-          <p:cNvPr id="15" name="Text 13"/>
-          <p:cNvSpPr/>
-          <p:nvPr/>
-        </p:nvSpPr>
-        <p:spPr>
-          <a:xfrm>
-            <a:off x="457200" y="4069080"/>
-            <a:ext cx="3749040" cy="548640"/>
-          </a:xfrm>
-          <a:prstGeom prst="rect">
-            <a:avLst/>
-          </a:prstGeom>
-          <a:noFill/>
-          <a:ln/>
-        </p:spPr>
-        <p:txBody>
-          <a:bodyPr wrap="square" rtlCol="0" anchor="ctr"/>
-          <a:lstStyle/>
-          <a:p>
-            <a:pPr indent="0" marL="0">
-              <a:buNone/>
-            </a:pPr>
-            <a:r>
-              <a:rPr lang="en-US" sz="1200" dirty="0">
-                <a:solidFill>
-                  <a:srgbClr val="1E293B"/>
-                </a:solidFill>
-              </a:rPr>
-              <a:t>+ Cree que el mercado necesita este servicio urgentemente</a:t>
-            </a:r>
-            <a:endParaRPr lang="en-US" sz="1200" dirty="0"/>
-          </a:p>
-        </p:txBody>
-      </p:sp>
-      <p:sp>
-        <p:nvSpPr>
-          <p:cNvPr id="16" name="Shape 14"/>
-          <p:cNvSpPr/>
-          <p:nvPr/>
-        </p:nvSpPr>
-        <p:spPr>
-          <a:xfrm>
-            <a:off x="4754880" y="2240280"/>
-            <a:ext cx="4114800" cy="2606040"/>
+          <p:cNvPr id="12" name="Shape 10"/>
+          <p:cNvSpPr/>
+          <p:nvPr/>
+        </p:nvSpPr>
+        <p:spPr>
+          <a:xfrm>
+            <a:off x="274320" y="2514600"/>
+            <a:ext cx="4206240" cy="2377440"/>
           </a:xfrm>
           <a:prstGeom prst="roundRect">
             <a:avLst>
-              <a:gd name="adj" fmla="val 3509"/>
+              <a:gd name="adj" fmla="val 3846"/>
             </a:avLst>
           </a:prstGeom>
           <a:solidFill>
@@ -11024,7 +10954,7 @@
           </a:solidFill>
           <a:ln w="12700">
             <a:solidFill>
-              <a:srgbClr val="DCE8F5"/>
+              <a:srgbClr val="D1FAE5"/>
             </a:solidFill>
             <a:prstDash val="solid"/>
           </a:ln>
@@ -11039,14 +10969,14 @@
       </p:sp>
       <p:sp>
         <p:nvSpPr>
-          <p:cNvPr id="17" name="Text 15"/>
-          <p:cNvSpPr/>
-          <p:nvPr/>
-        </p:nvSpPr>
-        <p:spPr>
-          <a:xfrm>
-            <a:off x="4937760" y="2331720"/>
-            <a:ext cx="3749040" cy="411480"/>
+          <p:cNvPr id="13" name="Text 11"/>
+          <p:cNvSpPr/>
+          <p:nvPr/>
+        </p:nvSpPr>
+        <p:spPr>
+          <a:xfrm>
+            <a:off x="457200" y="2587752"/>
+            <a:ext cx="3840480" cy="384048"/>
           </a:xfrm>
           <a:prstGeom prst="rect">
             <a:avLst/>
@@ -11064,10 +10994,188 @@
             <a:r>
               <a:rPr lang="en-US" sz="1300" b="1" dirty="0">
                 <a:solidFill>
+                  <a:srgbClr val="16A34A"/>
+                </a:solidFill>
+              </a:rPr>
+              <a:t>✅  Insights Positivos</a:t>
+            </a:r>
+            <a:endParaRPr lang="en-US" sz="1300" dirty="0"/>
+          </a:p>
+        </p:txBody>
+      </p:sp>
+      <p:sp>
+        <p:nvSpPr>
+          <p:cNvPr id="14" name="Text 12"/>
+          <p:cNvSpPr/>
+          <p:nvPr/>
+        </p:nvSpPr>
+        <p:spPr>
+          <a:xfrm>
+            <a:off x="457200" y="3017520"/>
+            <a:ext cx="3840480" cy="530352"/>
+          </a:xfrm>
+          <a:prstGeom prst="rect">
+            <a:avLst/>
+          </a:prstGeom>
+          <a:noFill/>
+          <a:ln/>
+        </p:spPr>
+        <p:txBody>
+          <a:bodyPr wrap="square" rtlCol="0" anchor="ctr"/>
+          <a:lstStyle/>
+          <a:p>
+            <a:pPr indent="0" marL="0">
+              <a:buNone/>
+            </a:pPr>
+            <a:r>
+              <a:rPr lang="en-US" sz="1200" dirty="0">
+                <a:solidFill>
+                  <a:srgbClr val="1E293B"/>
+                </a:solidFill>
+              </a:rPr>
+              <a:t>＋  Alta receptividad general al servicio de CheckAuto</a:t>
+            </a:r>
+            <a:endParaRPr lang="en-US" sz="1200" dirty="0"/>
+          </a:p>
+        </p:txBody>
+      </p:sp>
+      <p:sp>
+        <p:nvSpPr>
+          <p:cNvPr id="15" name="Text 13"/>
+          <p:cNvSpPr/>
+          <p:nvPr/>
+        </p:nvSpPr>
+        <p:spPr>
+          <a:xfrm>
+            <a:off x="457200" y="3611880"/>
+            <a:ext cx="3840480" cy="530352"/>
+          </a:xfrm>
+          <a:prstGeom prst="rect">
+            <a:avLst/>
+          </a:prstGeom>
+          <a:noFill/>
+          <a:ln/>
+        </p:spPr>
+        <p:txBody>
+          <a:bodyPr wrap="square" rtlCol="0" anchor="ctr"/>
+          <a:lstStyle/>
+          <a:p>
+            <a:pPr indent="0" marL="0">
+              <a:buNone/>
+            </a:pPr>
+            <a:r>
+              <a:rPr lang="en-US" sz="1200" dirty="0">
+                <a:solidFill>
+                  <a:srgbClr val="1E293B"/>
+                </a:solidFill>
+              </a:rPr>
+              <a:t>＋  Disposición a pagar por tranquilidad y seguridad</a:t>
+            </a:r>
+            <a:endParaRPr lang="en-US" sz="1200" dirty="0"/>
+          </a:p>
+        </p:txBody>
+      </p:sp>
+      <p:sp>
+        <p:nvSpPr>
+          <p:cNvPr id="16" name="Text 14"/>
+          <p:cNvSpPr/>
+          <p:nvPr/>
+        </p:nvSpPr>
+        <p:spPr>
+          <a:xfrm>
+            <a:off x="457200" y="4206240"/>
+            <a:ext cx="3840480" cy="530352"/>
+          </a:xfrm>
+          <a:prstGeom prst="rect">
+            <a:avLst/>
+          </a:prstGeom>
+          <a:noFill/>
+          <a:ln/>
+        </p:spPr>
+        <p:txBody>
+          <a:bodyPr wrap="square" rtlCol="0" anchor="ctr"/>
+          <a:lstStyle/>
+          <a:p>
+            <a:pPr indent="0" marL="0">
+              <a:buNone/>
+            </a:pPr>
+            <a:r>
+              <a:rPr lang="en-US" sz="1200" dirty="0">
+                <a:solidFill>
+                  <a:srgbClr val="1E293B"/>
+                </a:solidFill>
+              </a:rPr>
+              <a:t>＋  Prefieren reportes digitales con fotos y diagnóstico claro</a:t>
+            </a:r>
+            <a:endParaRPr lang="en-US" sz="1200" dirty="0"/>
+          </a:p>
+        </p:txBody>
+      </p:sp>
+      <p:sp>
+        <p:nvSpPr>
+          <p:cNvPr id="17" name="Shape 15"/>
+          <p:cNvSpPr/>
+          <p:nvPr/>
+        </p:nvSpPr>
+        <p:spPr>
+          <a:xfrm>
+            <a:off x="4663440" y="2514600"/>
+            <a:ext cx="4206240" cy="2377440"/>
+          </a:xfrm>
+          <a:prstGeom prst="roundRect">
+            <a:avLst>
+              <a:gd name="adj" fmla="val 3846"/>
+            </a:avLst>
+          </a:prstGeom>
+          <a:solidFill>
+            <a:srgbClr val="FFFFFF"/>
+          </a:solidFill>
+          <a:ln w="12700">
+            <a:solidFill>
+              <a:srgbClr val="FEE2E2"/>
+            </a:solidFill>
+            <a:prstDash val="solid"/>
+          </a:ln>
+          <a:effectLst>
+            <a:outerShdw sx="100000" sy="100000" kx="0" ky="0" algn="bl" rotWithShape="0" blurRad="101600" dist="38100" dir="2700000">
+              <a:srgbClr val="000000">
+                <a:alpha val="12000"/>
+              </a:srgbClr>
+            </a:outerShdw>
+          </a:effectLst>
+        </p:spPr>
+      </p:sp>
+      <p:sp>
+        <p:nvSpPr>
+          <p:cNvPr id="18" name="Text 16"/>
+          <p:cNvSpPr/>
+          <p:nvPr/>
+        </p:nvSpPr>
+        <p:spPr>
+          <a:xfrm>
+            <a:off x="4846320" y="2587752"/>
+            <a:ext cx="3840480" cy="384048"/>
+          </a:xfrm>
+          <a:prstGeom prst="rect">
+            <a:avLst/>
+          </a:prstGeom>
+          <a:noFill/>
+          <a:ln/>
+        </p:spPr>
+        <p:txBody>
+          <a:bodyPr wrap="square" lIns="0" tIns="0" rIns="0" bIns="0" rtlCol="0" anchor="ctr"/>
+          <a:lstStyle/>
+          <a:p>
+            <a:pPr indent="0" marL="0">
+              <a:buNone/>
+            </a:pPr>
+            <a:r>
+              <a:rPr lang="en-US" sz="1300" b="1" dirty="0">
+                <a:solidFill>
                   <a:srgbClr val="DC2626"/>
                 </a:solidFill>
               </a:rPr>
-              <a:t>⚠️  Insights Negativos</a:t>
+              <a:t>⚠️  Insights Negativos / Oportunidades</a:t>
             </a:r>
             <a:endParaRPr lang="en-US" sz="1300" dirty="0"/>
           </a:p>
@@ -11075,14 +11183,14 @@
       </p:sp>
       <p:sp>
         <p:nvSpPr>
-          <p:cNvPr id="18" name="Text 16"/>
-          <p:cNvSpPr/>
-          <p:nvPr/>
-        </p:nvSpPr>
-        <p:spPr>
-          <a:xfrm>
-            <a:off x="4937760" y="2788920"/>
-            <a:ext cx="3749040" cy="548640"/>
+          <p:cNvPr id="19" name="Text 17"/>
+          <p:cNvSpPr/>
+          <p:nvPr/>
+        </p:nvSpPr>
+        <p:spPr>
+          <a:xfrm>
+            <a:off x="4846320" y="3017520"/>
+            <a:ext cx="3840480" cy="530352"/>
           </a:xfrm>
           <a:prstGeom prst="rect">
             <a:avLst/>
@@ -11103,7 +11211,7 @@
                   <a:srgbClr val="1E293B"/>
                 </a:solidFill>
               </a:rPr>
-              <a:t>- Preocupa la competencia si CheckAuto tiene talleres propios</a:t>
+              <a:t>－  Desconfianza en la imparcialidad del inspector</a:t>
             </a:r>
             <a:endParaRPr lang="en-US" sz="1200" dirty="0"/>
           </a:p>
@@ -11111,14 +11219,14 @@
       </p:sp>
       <p:sp>
         <p:nvSpPr>
-          <p:cNvPr id="19" name="Text 17"/>
-          <p:cNvSpPr/>
-          <p:nvPr/>
-        </p:nvSpPr>
-        <p:spPr>
-          <a:xfrm>
-            <a:off x="4937760" y="3429000"/>
-            <a:ext cx="3749040" cy="548640"/>
+          <p:cNvPr id="20" name="Text 18"/>
+          <p:cNvSpPr/>
+          <p:nvPr/>
+        </p:nvSpPr>
+        <p:spPr>
+          <a:xfrm>
+            <a:off x="4846320" y="3611880"/>
+            <a:ext cx="3840480" cy="530352"/>
           </a:xfrm>
           <a:prstGeom prst="rect">
             <a:avLst/>
@@ -11139,7 +11247,7 @@
                   <a:srgbClr val="1E293B"/>
                 </a:solidFill>
               </a:rPr>
-              <a:t>- Exige capacitación adecuada del personal</a:t>
+              <a:t>－  Preocupación por tiempos de espera del servicio</a:t>
             </a:r>
             <a:endParaRPr lang="en-US" sz="1200" dirty="0"/>
           </a:p>
@@ -11147,14 +11255,14 @@
       </p:sp>
       <p:sp>
         <p:nvSpPr>
-          <p:cNvPr id="20" name="Text 18"/>
-          <p:cNvSpPr/>
-          <p:nvPr/>
-        </p:nvSpPr>
-        <p:spPr>
-          <a:xfrm>
-            <a:off x="4937760" y="4069080"/>
-            <a:ext cx="3749040" cy="548640"/>
+          <p:cNvPr id="21" name="Text 19"/>
+          <p:cNvSpPr/>
+          <p:nvPr/>
+        </p:nvSpPr>
+        <p:spPr>
+          <a:xfrm>
+            <a:off x="4846320" y="4206240"/>
+            <a:ext cx="3840480" cy="530352"/>
           </a:xfrm>
           <a:prstGeom prst="rect">
             <a:avLst/>
@@ -11175,7 +11283,7 @@
                   <a:srgbClr val="1E293B"/>
                 </a:solidFill>
               </a:rPr>
-              <a:t>- Quiere claridad en los estándares de inspección</a:t>
+              <a:t>－  Falta de claridad en qué incluye exactamente cada plan</a:t>
             </a:r>
             <a:endParaRPr lang="en-US" sz="1200" dirty="0"/>
           </a:p>
@@ -11308,17 +11416,17 @@
         <p:spPr>
           <a:xfrm>
             <a:off x="274320" y="960120"/>
-            <a:ext cx="3931920" cy="2560320"/>
+            <a:ext cx="4160520" cy="2834640"/>
           </a:xfrm>
           <a:prstGeom prst="roundRect">
             <a:avLst>
-              <a:gd name="adj" fmla="val 3571"/>
+              <a:gd name="adj" fmla="val 3871"/>
             </a:avLst>
           </a:prstGeom>
           <a:solidFill>
             <a:srgbClr val="EBF2FC"/>
           </a:solidFill>
-          <a:ln w="25400">
+          <a:ln w="31750">
             <a:solidFill>
               <a:srgbClr val="1E4D8C"/>
             </a:solidFill>
@@ -11341,8 +11449,44 @@
         </p:nvSpPr>
         <p:spPr>
           <a:xfrm>
-            <a:off x="274320" y="960120"/>
-            <a:ext cx="3931920" cy="2560320"/>
+            <a:off x="274320" y="1463040"/>
+            <a:ext cx="4160520" cy="731520"/>
+          </a:xfrm>
+          <a:prstGeom prst="rect">
+            <a:avLst/>
+          </a:prstGeom>
+          <a:noFill/>
+          <a:ln/>
+        </p:spPr>
+        <p:txBody>
+          <a:bodyPr wrap="square" lIns="0" tIns="0" rIns="0" bIns="0" rtlCol="0" anchor="ctr"/>
+          <a:lstStyle/>
+          <a:p>
+            <a:pPr algn="ctr" indent="0" marL="0">
+              <a:buNone/>
+            </a:pPr>
+            <a:r>
+              <a:rPr lang="en-US" sz="3600" dirty="0">
+                <a:solidFill>
+                  <a:srgbClr val="000000"/>
+                </a:solidFill>
+              </a:rPr>
+              <a:t>📷</a:t>
+            </a:r>
+            <a:endParaRPr lang="en-US" sz="3600" dirty="0"/>
+          </a:p>
+        </p:txBody>
+      </p:sp>
+      <p:sp>
+        <p:nvSpPr>
+          <p:cNvPr id="7" name="Text 5"/>
+          <p:cNvSpPr/>
+          <p:nvPr/>
+        </p:nvSpPr>
+        <p:spPr>
+          <a:xfrm>
+            <a:off x="274320" y="2240280"/>
+            <a:ext cx="4160520" cy="777240"/>
           </a:xfrm>
           <a:prstGeom prst="rect">
             <a:avLst/>
@@ -11358,41 +11502,55 @@
               <a:buNone/>
             </a:pPr>
             <a:r>
-              <a:rPr lang="en-US" sz="2000" i="1" dirty="0">
+              <a:rPr lang="en-US" sz="1100" i="1" dirty="0">
                 <a:solidFill>
                   <a:srgbClr val="1E4D8C"/>
                 </a:solidFill>
               </a:rPr>
-              <a:t>📸</a:t>
-            </a:r>
-            <a:endParaRPr lang="en-US" sz="2000" dirty="0"/>
+              <a:t>Insertar captura</a:t>
+            </a:r>
+            <a:endParaRPr lang="en-US" sz="1100" dirty="0"/>
           </a:p>
           <a:p>
             <a:pPr algn="ctr" indent="0" marL="0">
               <a:buNone/>
             </a:pPr>
             <a:r>
-              <a:rPr lang="en-US" sz="2000" i="1" dirty="0">
+              <a:rPr lang="en-US" sz="1100" i="1" dirty="0">
                 <a:solidFill>
                   <a:srgbClr val="1E4D8C"/>
                 </a:solidFill>
               </a:rPr>
-              <a:t>Foto del Focus Group</a:t>
-            </a:r>
-            <a:endParaRPr lang="en-US" sz="2000" dirty="0"/>
-          </a:p>
-        </p:txBody>
-      </p:sp>
-      <p:sp>
-        <p:nvSpPr>
-          <p:cNvPr id="7" name="Text 5"/>
-          <p:cNvSpPr/>
-          <p:nvPr/>
-        </p:nvSpPr>
-        <p:spPr>
-          <a:xfrm>
-            <a:off x="274320" y="3566160"/>
-            <a:ext cx="3931920" cy="320040"/>
+              <a:t>del Focus Group</a:t>
+            </a:r>
+            <a:endParaRPr lang="en-US" sz="1100" dirty="0"/>
+          </a:p>
+          <a:p>
+            <a:pPr algn="ctr" indent="0" marL="0">
+              <a:buNone/>
+            </a:pPr>
+            <a:r>
+              <a:rPr lang="en-US" sz="1100" i="1" dirty="0">
+                <a:solidFill>
+                  <a:srgbClr val="1E4D8C"/>
+                </a:solidFill>
+              </a:rPr>
+              <a:t>(Google Meet)</a:t>
+            </a:r>
+            <a:endParaRPr lang="en-US" sz="1100" dirty="0"/>
+          </a:p>
+        </p:txBody>
+      </p:sp>
+      <p:sp>
+        <p:nvSpPr>
+          <p:cNvPr id="8" name="Text 6"/>
+          <p:cNvSpPr/>
+          <p:nvPr/>
+        </p:nvSpPr>
+        <p:spPr>
+          <a:xfrm>
+            <a:off x="274320" y="3840480"/>
+            <a:ext cx="4160520" cy="320040"/>
           </a:xfrm>
           <a:prstGeom prst="rect">
             <a:avLst/>
@@ -11408,31 +11566,31 @@
               <a:buNone/>
             </a:pPr>
             <a:r>
-              <a:rPr lang="en-US" sz="1100" i="1" dirty="0">
+              <a:rPr lang="en-US" sz="1000" i="1" dirty="0">
                 <a:solidFill>
                   <a:srgbClr val="64748B"/>
                 </a:solidFill>
               </a:rPr>
-              <a:t>8 participantes · Duración 90 min · Modalidad presencial</a:t>
-            </a:r>
-            <a:endParaRPr lang="en-US" sz="1100" dirty="0"/>
-          </a:p>
-        </p:txBody>
-      </p:sp>
-      <p:sp>
-        <p:nvSpPr>
-          <p:cNvPr id="8" name="Shape 6"/>
-          <p:cNvSpPr/>
-          <p:nvPr/>
-        </p:nvSpPr>
-        <p:spPr>
-          <a:xfrm>
-            <a:off x="4480560" y="960120"/>
-            <a:ext cx="4389120" cy="1417320"/>
+              <a:t>11 participantes · Modalidad virtual · Google Meet</a:t>
+            </a:r>
+            <a:endParaRPr lang="en-US" sz="1000" dirty="0"/>
+          </a:p>
+        </p:txBody>
+      </p:sp>
+      <p:sp>
+        <p:nvSpPr>
+          <p:cNvPr id="9" name="Shape 7"/>
+          <p:cNvSpPr/>
+          <p:nvPr/>
+        </p:nvSpPr>
+        <p:spPr>
+          <a:xfrm>
+            <a:off x="4663440" y="960120"/>
+            <a:ext cx="4206240" cy="1691640"/>
           </a:xfrm>
           <a:prstGeom prst="roundRect">
             <a:avLst>
-              <a:gd name="adj" fmla="val 6452"/>
+              <a:gd name="adj" fmla="val 5405"/>
             </a:avLst>
           </a:prstGeom>
           <a:solidFill>
@@ -11455,14 +11613,14 @@
       </p:sp>
       <p:sp>
         <p:nvSpPr>
-          <p:cNvPr id="9" name="Text 7"/>
-          <p:cNvSpPr/>
-          <p:nvPr/>
-        </p:nvSpPr>
-        <p:spPr>
-          <a:xfrm>
-            <a:off x="4663440" y="1024128"/>
-            <a:ext cx="4023360" cy="365760"/>
+          <p:cNvPr id="10" name="Text 8"/>
+          <p:cNvSpPr/>
+          <p:nvPr/>
+        </p:nvSpPr>
+        <p:spPr>
+          <a:xfrm>
+            <a:off x="4846320" y="1033272"/>
+            <a:ext cx="3840480" cy="384048"/>
           </a:xfrm>
           <a:prstGeom prst="rect">
             <a:avLst/>
@@ -11491,14 +11649,14 @@
       </p:sp>
       <p:sp>
         <p:nvSpPr>
-          <p:cNvPr id="10" name="Text 8"/>
-          <p:cNvSpPr/>
-          <p:nvPr/>
-        </p:nvSpPr>
-        <p:spPr>
-          <a:xfrm>
-            <a:off x="4663440" y="1435608"/>
-            <a:ext cx="4023360" cy="822960"/>
+          <p:cNvPr id="11" name="Text 9"/>
+          <p:cNvSpPr/>
+          <p:nvPr/>
+        </p:nvSpPr>
+        <p:spPr>
+          <a:xfrm>
+            <a:off x="4846320" y="1463040"/>
+            <a:ext cx="3840480" cy="256032"/>
           </a:xfrm>
           <a:prstGeom prst="rect">
             <a:avLst/>
@@ -11514,55 +11672,139 @@
               <a:buNone/>
             </a:pPr>
             <a:r>
-              <a:rPr lang="en-US" sz="1200" dirty="0">
+              <a:rPr lang="en-US" sz="1100" dirty="0">
                 <a:solidFill>
                   <a:srgbClr val="1E293B"/>
                 </a:solidFill>
               </a:rPr>
-              <a:t>+  Alta receptividad al servicio de inspección
-</a:t>
-            </a:r>
+              <a:t>＋  El grupo valora tener un respaldo técnico y oficial</a:t>
+            </a:r>
+            <a:endParaRPr lang="en-US" sz="1100" dirty="0"/>
+          </a:p>
+        </p:txBody>
+      </p:sp>
+      <p:sp>
+        <p:nvSpPr>
+          <p:cNvPr id="12" name="Text 10"/>
+          <p:cNvSpPr/>
+          <p:nvPr/>
+        </p:nvSpPr>
+        <p:spPr>
+          <a:xfrm>
+            <a:off x="4846320" y="1737360"/>
+            <a:ext cx="3840480" cy="256032"/>
+          </a:xfrm>
+          <a:prstGeom prst="rect">
+            <a:avLst/>
+          </a:prstGeom>
+          <a:noFill/>
+          <a:ln/>
+        </p:spPr>
+        <p:txBody>
+          <a:bodyPr wrap="square" rtlCol="0" anchor="ctr"/>
+          <a:lstStyle/>
+          <a:p>
             <a:pPr indent="0" marL="0">
               <a:buNone/>
             </a:pPr>
             <a:r>
-              <a:rPr lang="en-US" sz="1200" dirty="0">
+              <a:rPr lang="en-US" sz="1100" dirty="0">
                 <a:solidFill>
                   <a:srgbClr val="1E293B"/>
                 </a:solidFill>
               </a:rPr>
-              <a:t>+  Disposición a pagar por tranquilidad
-</a:t>
-            </a:r>
+              <a:t>＋  Alta disposición a recomendar el servicio a familiares</a:t>
+            </a:r>
+            <a:endParaRPr lang="en-US" sz="1100" dirty="0"/>
+          </a:p>
+        </p:txBody>
+      </p:sp>
+      <p:sp>
+        <p:nvSpPr>
+          <p:cNvPr id="13" name="Text 11"/>
+          <p:cNvSpPr/>
+          <p:nvPr/>
+        </p:nvSpPr>
+        <p:spPr>
+          <a:xfrm>
+            <a:off x="4846320" y="2011680"/>
+            <a:ext cx="3840480" cy="256032"/>
+          </a:xfrm>
+          <a:prstGeom prst="rect">
+            <a:avLst/>
+          </a:prstGeom>
+          <a:noFill/>
+          <a:ln/>
+        </p:spPr>
+        <p:txBody>
+          <a:bodyPr wrap="square" rtlCol="0" anchor="ctr"/>
+          <a:lstStyle/>
+          <a:p>
             <a:pPr indent="0" marL="0">
               <a:buNone/>
             </a:pPr>
             <a:r>
-              <a:rPr lang="en-US" sz="1200" dirty="0">
+              <a:rPr lang="en-US" sz="1100" dirty="0">
                 <a:solidFill>
                   <a:srgbClr val="1E293B"/>
                 </a:solidFill>
               </a:rPr>
-              <a:t>+  Preferencia por reportes digitales con fotos</a:t>
-            </a:r>
-            <a:endParaRPr lang="en-US" sz="1200" dirty="0"/>
-          </a:p>
-        </p:txBody>
-      </p:sp>
-      <p:sp>
-        <p:nvSpPr>
-          <p:cNvPr id="11" name="Shape 9"/>
-          <p:cNvSpPr/>
-          <p:nvPr/>
-        </p:nvSpPr>
-        <p:spPr>
-          <a:xfrm>
-            <a:off x="4480560" y="2514600"/>
-            <a:ext cx="4389120" cy="1417320"/>
+              <a:t>＋  Prefieren el agendamiento digital por WhatsApp o app</a:t>
+            </a:r>
+            <a:endParaRPr lang="en-US" sz="1100" dirty="0"/>
+          </a:p>
+        </p:txBody>
+      </p:sp>
+      <p:sp>
+        <p:nvSpPr>
+          <p:cNvPr id="14" name="Text 12"/>
+          <p:cNvSpPr/>
+          <p:nvPr/>
+        </p:nvSpPr>
+        <p:spPr>
+          <a:xfrm>
+            <a:off x="4846320" y="2286000"/>
+            <a:ext cx="3840480" cy="256032"/>
+          </a:xfrm>
+          <a:prstGeom prst="rect">
+            <a:avLst/>
+          </a:prstGeom>
+          <a:noFill/>
+          <a:ln/>
+        </p:spPr>
+        <p:txBody>
+          <a:bodyPr wrap="square" rtlCol="0" anchor="ctr"/>
+          <a:lstStyle/>
+          <a:p>
+            <a:pPr indent="0" marL="0">
+              <a:buNone/>
+            </a:pPr>
+            <a:r>
+              <a:rPr lang="en-US" sz="1100" dirty="0">
+                <a:solidFill>
+                  <a:srgbClr val="1E293B"/>
+                </a:solidFill>
+              </a:rPr>
+              <a:t>＋  Consideran el precio razonable si el reporte incluye fotos</a:t>
+            </a:r>
+            <a:endParaRPr lang="en-US" sz="1100" dirty="0"/>
+          </a:p>
+        </p:txBody>
+      </p:sp>
+      <p:sp>
+        <p:nvSpPr>
+          <p:cNvPr id="15" name="Shape 13"/>
+          <p:cNvSpPr/>
+          <p:nvPr/>
+        </p:nvSpPr>
+        <p:spPr>
+          <a:xfrm>
+            <a:off x="4663440" y="2743200"/>
+            <a:ext cx="4206240" cy="1691640"/>
           </a:xfrm>
           <a:prstGeom prst="roundRect">
             <a:avLst>
-              <a:gd name="adj" fmla="val 6452"/>
+              <a:gd name="adj" fmla="val 5405"/>
             </a:avLst>
           </a:prstGeom>
           <a:solidFill>
@@ -11585,14 +11827,14 @@
       </p:sp>
       <p:sp>
         <p:nvSpPr>
-          <p:cNvPr id="12" name="Text 10"/>
-          <p:cNvSpPr/>
-          <p:nvPr/>
-        </p:nvSpPr>
-        <p:spPr>
-          <a:xfrm>
-            <a:off x="4663440" y="2578608"/>
-            <a:ext cx="4023360" cy="365760"/>
+          <p:cNvPr id="16" name="Text 14"/>
+          <p:cNvSpPr/>
+          <p:nvPr/>
+        </p:nvSpPr>
+        <p:spPr>
+          <a:xfrm>
+            <a:off x="4846320" y="2816352"/>
+            <a:ext cx="3840480" cy="384048"/>
           </a:xfrm>
           <a:prstGeom prst="rect">
             <a:avLst/>
@@ -11613,7 +11855,7 @@
                   <a:srgbClr val="DC2626"/>
                 </a:solidFill>
               </a:rPr>
-              <a:t>⚠️  Insights Negativos</a:t>
+              <a:t>⚠️  Insights Negativos / Oportunidades</a:t>
             </a:r>
             <a:endParaRPr lang="en-US" sz="1400" dirty="0"/>
           </a:p>
@@ -11621,14 +11863,14 @@
       </p:sp>
       <p:sp>
         <p:nvSpPr>
-          <p:cNvPr id="13" name="Text 11"/>
-          <p:cNvSpPr/>
-          <p:nvPr/>
-        </p:nvSpPr>
-        <p:spPr>
-          <a:xfrm>
-            <a:off x="4663440" y="2990088"/>
-            <a:ext cx="4023360" cy="822960"/>
+          <p:cNvPr id="17" name="Text 15"/>
+          <p:cNvSpPr/>
+          <p:nvPr/>
+        </p:nvSpPr>
+        <p:spPr>
+          <a:xfrm>
+            <a:off x="4846320" y="3246120"/>
+            <a:ext cx="3840480" cy="256032"/>
           </a:xfrm>
           <a:prstGeom prst="rect">
             <a:avLst/>
@@ -11644,44 +11886,128 @@
               <a:buNone/>
             </a:pPr>
             <a:r>
-              <a:rPr lang="en-US" sz="1200" dirty="0">
+              <a:rPr lang="en-US" sz="1100" dirty="0">
                 <a:solidFill>
                   <a:srgbClr val="1E293B"/>
                 </a:solidFill>
               </a:rPr>
-              <a:t>-  Desconfianza en la imparcialidad del inspector
-</a:t>
-            </a:r>
+              <a:t>－  Desconfianza en la imparcialidad del inspector</a:t>
+            </a:r>
+            <a:endParaRPr lang="en-US" sz="1100" dirty="0"/>
+          </a:p>
+        </p:txBody>
+      </p:sp>
+      <p:sp>
+        <p:nvSpPr>
+          <p:cNvPr id="18" name="Text 16"/>
+          <p:cNvSpPr/>
+          <p:nvPr/>
+        </p:nvSpPr>
+        <p:spPr>
+          <a:xfrm>
+            <a:off x="4846320" y="3520440"/>
+            <a:ext cx="3840480" cy="256032"/>
+          </a:xfrm>
+          <a:prstGeom prst="rect">
+            <a:avLst/>
+          </a:prstGeom>
+          <a:noFill/>
+          <a:ln/>
+        </p:spPr>
+        <p:txBody>
+          <a:bodyPr wrap="square" rtlCol="0" anchor="ctr"/>
+          <a:lstStyle/>
+          <a:p>
             <a:pPr indent="0" marL="0">
               <a:buNone/>
             </a:pPr>
             <a:r>
-              <a:rPr lang="en-US" sz="1200" dirty="0">
+              <a:rPr lang="en-US" sz="1100" dirty="0">
                 <a:solidFill>
                   <a:srgbClr val="1E293B"/>
                 </a:solidFill>
               </a:rPr>
-              <a:t>-  Preocupación por tiempos de espera
-</a:t>
-            </a:r>
+              <a:t>－  Preocupación por tiempos de espera prolongados</a:t>
+            </a:r>
+            <a:endParaRPr lang="en-US" sz="1100" dirty="0"/>
+          </a:p>
+        </p:txBody>
+      </p:sp>
+      <p:sp>
+        <p:nvSpPr>
+          <p:cNvPr id="19" name="Text 17"/>
+          <p:cNvSpPr/>
+          <p:nvPr/>
+        </p:nvSpPr>
+        <p:spPr>
+          <a:xfrm>
+            <a:off x="4846320" y="3794760"/>
+            <a:ext cx="3840480" cy="256032"/>
+          </a:xfrm>
+          <a:prstGeom prst="rect">
+            <a:avLst/>
+          </a:prstGeom>
+          <a:noFill/>
+          <a:ln/>
+        </p:spPr>
+        <p:txBody>
+          <a:bodyPr wrap="square" rtlCol="0" anchor="ctr"/>
+          <a:lstStyle/>
+          <a:p>
             <a:pPr indent="0" marL="0">
               <a:buNone/>
             </a:pPr>
             <a:r>
-              <a:rPr lang="en-US" sz="1200" dirty="0">
+              <a:rPr lang="en-US" sz="1100" dirty="0">
                 <a:solidFill>
                   <a:srgbClr val="1E293B"/>
                 </a:solidFill>
               </a:rPr>
-              <a:t>-  Falta de claridad en qué incluye cada plan</a:t>
-            </a:r>
-            <a:endParaRPr lang="en-US" sz="1200" dirty="0"/>
-          </a:p>
-        </p:txBody>
-      </p:sp>
-      <p:sp>
-        <p:nvSpPr>
-          <p:cNvPr id="14" name="Shape 12"/>
+              <a:t>－  Poca claridad sobre qué incluye cada plan de servicio</a:t>
+            </a:r>
+            <a:endParaRPr lang="en-US" sz="1100" dirty="0"/>
+          </a:p>
+        </p:txBody>
+      </p:sp>
+      <p:sp>
+        <p:nvSpPr>
+          <p:cNvPr id="20" name="Text 18"/>
+          <p:cNvSpPr/>
+          <p:nvPr/>
+        </p:nvSpPr>
+        <p:spPr>
+          <a:xfrm>
+            <a:off x="4846320" y="4069080"/>
+            <a:ext cx="3840480" cy="256032"/>
+          </a:xfrm>
+          <a:prstGeom prst="rect">
+            <a:avLst/>
+          </a:prstGeom>
+          <a:noFill/>
+          <a:ln/>
+        </p:spPr>
+        <p:txBody>
+          <a:bodyPr wrap="square" rtlCol="0" anchor="ctr"/>
+          <a:lstStyle/>
+          <a:p>
+            <a:pPr indent="0" marL="0">
+              <a:buNone/>
+            </a:pPr>
+            <a:r>
+              <a:rPr lang="en-US" sz="1100" dirty="0">
+                <a:solidFill>
+                  <a:srgbClr val="1E293B"/>
+                </a:solidFill>
+              </a:rPr>
+              <a:t>－  Solicitaron comparativa de precios vs competencia</a:t>
+            </a:r>
+            <a:endParaRPr lang="en-US" sz="1100" dirty="0"/>
+          </a:p>
+        </p:txBody>
+      </p:sp>
+      <p:sp>
+        <p:nvSpPr>
+          <p:cNvPr id="21" name="Shape 19"/>
           <p:cNvSpPr/>
           <p:nvPr/>
         </p:nvSpPr>
@@ -11708,7 +12034,7 @@
       </p:sp>
       <p:sp>
         <p:nvSpPr>
-          <p:cNvPr id="15" name="Text 13"/>
+          <p:cNvPr id="22" name="Text 20"/>
           <p:cNvSpPr/>
           <p:nvPr/>
         </p:nvSpPr>

</xml_diff>

<commit_message>
Add real photos for interviews and focus group
</commit_message>
<xml_diff>
--- a/CheckAuto_Presentacion.pptx
+++ b/CheckAuto_Presentacion.pptx
@@ -8613,9 +8613,32 @@
           </a:p>
         </p:txBody>
       </p:sp>
-      <p:sp>
-        <p:nvSpPr>
-          <p:cNvPr id="5" name="Shape 3"/>
+      <p:pic>
+        <p:nvPicPr>
+          <p:cNvPr id="5" name="Image 0" descr="C:\Users\Jhnn\Downloads\entrevista1.webp">    </p:cNvPr>
+          <p:cNvPicPr>
+            <a:picLocks noChangeAspect="1"/>
+          </p:cNvPicPr>
+          <p:nvPr/>
+        </p:nvPicPr>
+        <p:blipFill>
+          <a:blip r:embed="rId1"/>
+          <a:srcRect l="0" r="0" t="0" b="0"/>
+          <a:stretch/>
+        </p:blipFill>
+        <p:spPr>
+          <a:xfrm>
+            <a:off x="320040" y="960120"/>
+            <a:ext cx="2194560" cy="2331720"/>
+          </a:xfrm>
+          <a:prstGeom prst="rect">
+            <a:avLst/>
+          </a:prstGeom>
+        </p:spPr>
+      </p:pic>
+      <p:sp>
+        <p:nvSpPr>
+          <p:cNvPr id="6" name="Shape 3"/>
           <p:cNvSpPr/>
           <p:nvPr/>
         </p:nvSpPr>
@@ -8630,7 +8653,9 @@
             </a:avLst>
           </a:prstGeom>
           <a:solidFill>
-            <a:srgbClr val="EBF2FC"/>
+            <a:srgbClr val="FFFFFF">
+              <a:alpha val="0"/>
+            </a:srgbClr>
           </a:solidFill>
           <a:ln w="31750">
             <a:solidFill>
@@ -8638,104 +8663,11 @@
             </a:solidFill>
             <a:prstDash val="solid"/>
           </a:ln>
-          <a:effectLst>
-            <a:outerShdw sx="100000" sy="100000" kx="0" ky="0" algn="bl" rotWithShape="0" blurRad="101600" dist="38100" dir="2700000">
-              <a:srgbClr val="000000">
-                <a:alpha val="12000"/>
-              </a:srgbClr>
-            </a:outerShdw>
-          </a:effectLst>
-        </p:spPr>
-      </p:sp>
-      <p:sp>
-        <p:nvSpPr>
-          <p:cNvPr id="6" name="Text 4"/>
-          <p:cNvSpPr/>
-          <p:nvPr/>
-        </p:nvSpPr>
-        <p:spPr>
-          <a:xfrm>
-            <a:off x="320040" y="1417320"/>
-            <a:ext cx="2194560" cy="640080"/>
-          </a:xfrm>
-          <a:prstGeom prst="rect">
-            <a:avLst/>
-          </a:prstGeom>
-          <a:noFill/>
-          <a:ln/>
-        </p:spPr>
-        <p:txBody>
-          <a:bodyPr wrap="square" lIns="0" tIns="0" rIns="0" bIns="0" rtlCol="0" anchor="ctr"/>
-          <a:lstStyle/>
-          <a:p>
-            <a:pPr algn="ctr" indent="0" marL="0">
-              <a:buNone/>
-            </a:pPr>
-            <a:r>
-              <a:rPr lang="en-US" sz="3200" dirty="0">
-                <a:solidFill>
-                  <a:srgbClr val="000000"/>
-                </a:solidFill>
-              </a:rPr>
-              <a:t>📷</a:t>
-            </a:r>
-            <a:endParaRPr lang="en-US" sz="3200" dirty="0"/>
-          </a:p>
-        </p:txBody>
-      </p:sp>
-      <p:sp>
-        <p:nvSpPr>
-          <p:cNvPr id="7" name="Text 5"/>
-          <p:cNvSpPr/>
-          <p:nvPr/>
-        </p:nvSpPr>
-        <p:spPr>
-          <a:xfrm>
-            <a:off x="320040" y="2103120"/>
-            <a:ext cx="2194560" cy="640080"/>
-          </a:xfrm>
-          <a:prstGeom prst="rect">
-            <a:avLst/>
-          </a:prstGeom>
-          <a:noFill/>
-          <a:ln/>
-        </p:spPr>
-        <p:txBody>
-          <a:bodyPr wrap="square" rtlCol="0" anchor="ctr"/>
-          <a:lstStyle/>
-          <a:p>
-            <a:pPr algn="ctr" indent="0" marL="0">
-              <a:buNone/>
-            </a:pPr>
-            <a:r>
-              <a:rPr lang="en-US" sz="1000" i="1" dirty="0">
-                <a:solidFill>
-                  <a:srgbClr val="1E4D8C"/>
-                </a:solidFill>
-              </a:rPr>
-              <a:t>Insertar foto</a:t>
-            </a:r>
-            <a:endParaRPr lang="en-US" sz="1000" dirty="0"/>
-          </a:p>
-          <a:p>
-            <a:pPr algn="ctr" indent="0" marL="0">
-              <a:buNone/>
-            </a:pPr>
-            <a:r>
-              <a:rPr lang="en-US" sz="1000" i="1" dirty="0">
-                <a:solidFill>
-                  <a:srgbClr val="1E4D8C"/>
-                </a:solidFill>
-              </a:rPr>
-              <a:t>del entrevistado</a:t>
-            </a:r>
-            <a:endParaRPr lang="en-US" sz="1000" dirty="0"/>
-          </a:p>
-        </p:txBody>
-      </p:sp>
-      <p:sp>
-        <p:nvSpPr>
-          <p:cNvPr id="8" name="Shape 6"/>
+        </p:spPr>
+      </p:sp>
+      <p:sp>
+        <p:nvSpPr>
+          <p:cNvPr id="7" name="Shape 4"/>
           <p:cNvSpPr/>
           <p:nvPr/>
         </p:nvSpPr>
@@ -8769,7 +8701,7 @@
       </p:sp>
       <p:sp>
         <p:nvSpPr>
-          <p:cNvPr id="9" name="Text 7"/>
+          <p:cNvPr id="8" name="Text 5"/>
           <p:cNvSpPr/>
           <p:nvPr/>
         </p:nvSpPr>
@@ -8805,7 +8737,7 @@
       </p:sp>
       <p:sp>
         <p:nvSpPr>
-          <p:cNvPr id="10" name="Shape 8"/>
+          <p:cNvPr id="9" name="Shape 6"/>
           <p:cNvSpPr/>
           <p:nvPr/>
         </p:nvSpPr>
@@ -8830,7 +8762,7 @@
       </p:sp>
       <p:sp>
         <p:nvSpPr>
-          <p:cNvPr id="11" name="Text 9"/>
+          <p:cNvPr id="10" name="Text 7"/>
           <p:cNvSpPr/>
           <p:nvPr/>
         </p:nvSpPr>
@@ -8866,7 +8798,7 @@
       </p:sp>
       <p:sp>
         <p:nvSpPr>
-          <p:cNvPr id="12" name="Shape 10"/>
+          <p:cNvPr id="11" name="Shape 8"/>
           <p:cNvSpPr/>
           <p:nvPr/>
         </p:nvSpPr>
@@ -8900,7 +8832,7 @@
       </p:sp>
       <p:sp>
         <p:nvSpPr>
-          <p:cNvPr id="13" name="Text 11"/>
+          <p:cNvPr id="12" name="Text 9"/>
           <p:cNvSpPr/>
           <p:nvPr/>
         </p:nvSpPr>
@@ -8936,7 +8868,7 @@
       </p:sp>
       <p:sp>
         <p:nvSpPr>
-          <p:cNvPr id="14" name="Text 12"/>
+          <p:cNvPr id="13" name="Text 10"/>
           <p:cNvSpPr/>
           <p:nvPr/>
         </p:nvSpPr>
@@ -8972,7 +8904,7 @@
       </p:sp>
       <p:sp>
         <p:nvSpPr>
-          <p:cNvPr id="15" name="Text 13"/>
+          <p:cNvPr id="14" name="Text 11"/>
           <p:cNvSpPr/>
           <p:nvPr/>
         </p:nvSpPr>
@@ -9008,7 +8940,7 @@
       </p:sp>
       <p:sp>
         <p:nvSpPr>
-          <p:cNvPr id="16" name="Text 14"/>
+          <p:cNvPr id="15" name="Text 12"/>
           <p:cNvSpPr/>
           <p:nvPr/>
         </p:nvSpPr>
@@ -9044,7 +8976,7 @@
       </p:sp>
       <p:sp>
         <p:nvSpPr>
-          <p:cNvPr id="17" name="Shape 15"/>
+          <p:cNvPr id="16" name="Shape 13"/>
           <p:cNvSpPr/>
           <p:nvPr/>
         </p:nvSpPr>
@@ -9078,7 +9010,7 @@
       </p:sp>
       <p:sp>
         <p:nvSpPr>
-          <p:cNvPr id="18" name="Text 16"/>
+          <p:cNvPr id="17" name="Text 14"/>
           <p:cNvSpPr/>
           <p:nvPr/>
         </p:nvSpPr>
@@ -9114,7 +9046,7 @@
       </p:sp>
       <p:sp>
         <p:nvSpPr>
-          <p:cNvPr id="19" name="Text 17"/>
+          <p:cNvPr id="18" name="Text 15"/>
           <p:cNvSpPr/>
           <p:nvPr/>
         </p:nvSpPr>
@@ -9150,7 +9082,7 @@
       </p:sp>
       <p:sp>
         <p:nvSpPr>
-          <p:cNvPr id="20" name="Text 18"/>
+          <p:cNvPr id="19" name="Text 16"/>
           <p:cNvSpPr/>
           <p:nvPr/>
         </p:nvSpPr>
@@ -9186,7 +9118,7 @@
       </p:sp>
       <p:sp>
         <p:nvSpPr>
-          <p:cNvPr id="21" name="Text 19"/>
+          <p:cNvPr id="20" name="Text 17"/>
           <p:cNvSpPr/>
           <p:nvPr/>
         </p:nvSpPr>
@@ -9338,9 +9270,32 @@
           </a:p>
         </p:txBody>
       </p:sp>
-      <p:sp>
-        <p:nvSpPr>
-          <p:cNvPr id="5" name="Shape 3"/>
+      <p:pic>
+        <p:nvPicPr>
+          <p:cNvPr id="5" name="Image 0" descr="C:\Users\Jhnn\Downloads\entrevista2.webp">    </p:cNvPr>
+          <p:cNvPicPr>
+            <a:picLocks noChangeAspect="1"/>
+          </p:cNvPicPr>
+          <p:nvPr/>
+        </p:nvPicPr>
+        <p:blipFill>
+          <a:blip r:embed="rId1"/>
+          <a:srcRect l="0" r="0" t="0" b="0"/>
+          <a:stretch/>
+        </p:blipFill>
+        <p:spPr>
+          <a:xfrm>
+            <a:off x="320040" y="960120"/>
+            <a:ext cx="2194560" cy="2331720"/>
+          </a:xfrm>
+          <a:prstGeom prst="rect">
+            <a:avLst/>
+          </a:prstGeom>
+        </p:spPr>
+      </p:pic>
+      <p:sp>
+        <p:nvSpPr>
+          <p:cNvPr id="6" name="Shape 3"/>
           <p:cNvSpPr/>
           <p:nvPr/>
         </p:nvSpPr>
@@ -9355,7 +9310,9 @@
             </a:avLst>
           </a:prstGeom>
           <a:solidFill>
-            <a:srgbClr val="EBF2FC"/>
+            <a:srgbClr val="FFFFFF">
+              <a:alpha val="0"/>
+            </a:srgbClr>
           </a:solidFill>
           <a:ln w="31750">
             <a:solidFill>
@@ -9363,104 +9320,11 @@
             </a:solidFill>
             <a:prstDash val="solid"/>
           </a:ln>
-          <a:effectLst>
-            <a:outerShdw sx="100000" sy="100000" kx="0" ky="0" algn="bl" rotWithShape="0" blurRad="101600" dist="38100" dir="2700000">
-              <a:srgbClr val="000000">
-                <a:alpha val="12000"/>
-              </a:srgbClr>
-            </a:outerShdw>
-          </a:effectLst>
-        </p:spPr>
-      </p:sp>
-      <p:sp>
-        <p:nvSpPr>
-          <p:cNvPr id="6" name="Text 4"/>
-          <p:cNvSpPr/>
-          <p:nvPr/>
-        </p:nvSpPr>
-        <p:spPr>
-          <a:xfrm>
-            <a:off x="320040" y="1417320"/>
-            <a:ext cx="2194560" cy="640080"/>
-          </a:xfrm>
-          <a:prstGeom prst="rect">
-            <a:avLst/>
-          </a:prstGeom>
-          <a:noFill/>
-          <a:ln/>
-        </p:spPr>
-        <p:txBody>
-          <a:bodyPr wrap="square" lIns="0" tIns="0" rIns="0" bIns="0" rtlCol="0" anchor="ctr"/>
-          <a:lstStyle/>
-          <a:p>
-            <a:pPr algn="ctr" indent="0" marL="0">
-              <a:buNone/>
-            </a:pPr>
-            <a:r>
-              <a:rPr lang="en-US" sz="3200" dirty="0">
-                <a:solidFill>
-                  <a:srgbClr val="000000"/>
-                </a:solidFill>
-              </a:rPr>
-              <a:t>📷</a:t>
-            </a:r>
-            <a:endParaRPr lang="en-US" sz="3200" dirty="0"/>
-          </a:p>
-        </p:txBody>
-      </p:sp>
-      <p:sp>
-        <p:nvSpPr>
-          <p:cNvPr id="7" name="Text 5"/>
-          <p:cNvSpPr/>
-          <p:nvPr/>
-        </p:nvSpPr>
-        <p:spPr>
-          <a:xfrm>
-            <a:off x="320040" y="2103120"/>
-            <a:ext cx="2194560" cy="640080"/>
-          </a:xfrm>
-          <a:prstGeom prst="rect">
-            <a:avLst/>
-          </a:prstGeom>
-          <a:noFill/>
-          <a:ln/>
-        </p:spPr>
-        <p:txBody>
-          <a:bodyPr wrap="square" rtlCol="0" anchor="ctr"/>
-          <a:lstStyle/>
-          <a:p>
-            <a:pPr algn="ctr" indent="0" marL="0">
-              <a:buNone/>
-            </a:pPr>
-            <a:r>
-              <a:rPr lang="en-US" sz="1000" i="1" dirty="0">
-                <a:solidFill>
-                  <a:srgbClr val="1E4D8C"/>
-                </a:solidFill>
-              </a:rPr>
-              <a:t>Insertar foto</a:t>
-            </a:r>
-            <a:endParaRPr lang="en-US" sz="1000" dirty="0"/>
-          </a:p>
-          <a:p>
-            <a:pPr algn="ctr" indent="0" marL="0">
-              <a:buNone/>
-            </a:pPr>
-            <a:r>
-              <a:rPr lang="en-US" sz="1000" i="1" dirty="0">
-                <a:solidFill>
-                  <a:srgbClr val="1E4D8C"/>
-                </a:solidFill>
-              </a:rPr>
-              <a:t>del entrevistado</a:t>
-            </a:r>
-            <a:endParaRPr lang="en-US" sz="1000" dirty="0"/>
-          </a:p>
-        </p:txBody>
-      </p:sp>
-      <p:sp>
-        <p:nvSpPr>
-          <p:cNvPr id="8" name="Shape 6"/>
+        </p:spPr>
+      </p:sp>
+      <p:sp>
+        <p:nvSpPr>
+          <p:cNvPr id="7" name="Shape 4"/>
           <p:cNvSpPr/>
           <p:nvPr/>
         </p:nvSpPr>
@@ -9494,7 +9358,7 @@
       </p:sp>
       <p:sp>
         <p:nvSpPr>
-          <p:cNvPr id="9" name="Text 7"/>
+          <p:cNvPr id="8" name="Text 5"/>
           <p:cNvSpPr/>
           <p:nvPr/>
         </p:nvSpPr>
@@ -9530,7 +9394,7 @@
       </p:sp>
       <p:sp>
         <p:nvSpPr>
-          <p:cNvPr id="10" name="Shape 8"/>
+          <p:cNvPr id="9" name="Shape 6"/>
           <p:cNvSpPr/>
           <p:nvPr/>
         </p:nvSpPr>
@@ -9555,7 +9419,7 @@
       </p:sp>
       <p:sp>
         <p:nvSpPr>
-          <p:cNvPr id="11" name="Text 9"/>
+          <p:cNvPr id="10" name="Text 7"/>
           <p:cNvSpPr/>
           <p:nvPr/>
         </p:nvSpPr>
@@ -9591,7 +9455,7 @@
       </p:sp>
       <p:sp>
         <p:nvSpPr>
-          <p:cNvPr id="12" name="Shape 10"/>
+          <p:cNvPr id="11" name="Shape 8"/>
           <p:cNvSpPr/>
           <p:nvPr/>
         </p:nvSpPr>
@@ -9625,7 +9489,7 @@
       </p:sp>
       <p:sp>
         <p:nvSpPr>
-          <p:cNvPr id="13" name="Text 11"/>
+          <p:cNvPr id="12" name="Text 9"/>
           <p:cNvSpPr/>
           <p:nvPr/>
         </p:nvSpPr>
@@ -9661,7 +9525,7 @@
       </p:sp>
       <p:sp>
         <p:nvSpPr>
-          <p:cNvPr id="14" name="Text 12"/>
+          <p:cNvPr id="13" name="Text 10"/>
           <p:cNvSpPr/>
           <p:nvPr/>
         </p:nvSpPr>
@@ -9697,7 +9561,7 @@
       </p:sp>
       <p:sp>
         <p:nvSpPr>
-          <p:cNvPr id="15" name="Text 13"/>
+          <p:cNvPr id="14" name="Text 11"/>
           <p:cNvSpPr/>
           <p:nvPr/>
         </p:nvSpPr>
@@ -9733,7 +9597,7 @@
       </p:sp>
       <p:sp>
         <p:nvSpPr>
-          <p:cNvPr id="16" name="Text 14"/>
+          <p:cNvPr id="15" name="Text 12"/>
           <p:cNvSpPr/>
           <p:nvPr/>
         </p:nvSpPr>
@@ -9769,7 +9633,7 @@
       </p:sp>
       <p:sp>
         <p:nvSpPr>
-          <p:cNvPr id="17" name="Shape 15"/>
+          <p:cNvPr id="16" name="Shape 13"/>
           <p:cNvSpPr/>
           <p:nvPr/>
         </p:nvSpPr>
@@ -9803,7 +9667,7 @@
       </p:sp>
       <p:sp>
         <p:nvSpPr>
-          <p:cNvPr id="18" name="Text 16"/>
+          <p:cNvPr id="17" name="Text 14"/>
           <p:cNvSpPr/>
           <p:nvPr/>
         </p:nvSpPr>
@@ -9839,7 +9703,7 @@
       </p:sp>
       <p:sp>
         <p:nvSpPr>
-          <p:cNvPr id="19" name="Text 17"/>
+          <p:cNvPr id="18" name="Text 15"/>
           <p:cNvSpPr/>
           <p:nvPr/>
         </p:nvSpPr>
@@ -9875,7 +9739,7 @@
       </p:sp>
       <p:sp>
         <p:nvSpPr>
-          <p:cNvPr id="20" name="Text 18"/>
+          <p:cNvPr id="19" name="Text 16"/>
           <p:cNvSpPr/>
           <p:nvPr/>
         </p:nvSpPr>
@@ -9911,7 +9775,7 @@
       </p:sp>
       <p:sp>
         <p:nvSpPr>
-          <p:cNvPr id="21" name="Text 19"/>
+          <p:cNvPr id="20" name="Text 17"/>
           <p:cNvSpPr/>
           <p:nvPr/>
         </p:nvSpPr>
@@ -11407,9 +11271,32 @@
           </a:p>
         </p:txBody>
       </p:sp>
-      <p:sp>
-        <p:nvSpPr>
-          <p:cNvPr id="5" name="Shape 3"/>
+      <p:pic>
+        <p:nvPicPr>
+          <p:cNvPr id="5" name="Image 0" descr="C:\Users\Jhnn\Downloads\focusgroup.webp">    </p:cNvPr>
+          <p:cNvPicPr>
+            <a:picLocks noChangeAspect="1"/>
+          </p:cNvPicPr>
+          <p:nvPr/>
+        </p:nvPicPr>
+        <p:blipFill>
+          <a:blip r:embed="rId1"/>
+          <a:srcRect l="0" r="0" t="0" b="0"/>
+          <a:stretch/>
+        </p:blipFill>
+        <p:spPr>
+          <a:xfrm>
+            <a:off x="274320" y="960120"/>
+            <a:ext cx="4160520" cy="2834640"/>
+          </a:xfrm>
+          <a:prstGeom prst="rect">
+            <a:avLst/>
+          </a:prstGeom>
+        </p:spPr>
+      </p:pic>
+      <p:sp>
+        <p:nvSpPr>
+          <p:cNvPr id="6" name="Shape 3"/>
           <p:cNvSpPr/>
           <p:nvPr/>
         </p:nvSpPr>
@@ -11424,7 +11311,9 @@
             </a:avLst>
           </a:prstGeom>
           <a:solidFill>
-            <a:srgbClr val="EBF2FC"/>
+            <a:srgbClr val="FFFFFF">
+              <a:alpha val="0"/>
+            </a:srgbClr>
           </a:solidFill>
           <a:ln w="31750">
             <a:solidFill>
@@ -11432,118 +11321,11 @@
             </a:solidFill>
             <a:prstDash val="solid"/>
           </a:ln>
-          <a:effectLst>
-            <a:outerShdw sx="100000" sy="100000" kx="0" ky="0" algn="bl" rotWithShape="0" blurRad="101600" dist="38100" dir="2700000">
-              <a:srgbClr val="000000">
-                <a:alpha val="12000"/>
-              </a:srgbClr>
-            </a:outerShdw>
-          </a:effectLst>
-        </p:spPr>
-      </p:sp>
-      <p:sp>
-        <p:nvSpPr>
-          <p:cNvPr id="6" name="Text 4"/>
-          <p:cNvSpPr/>
-          <p:nvPr/>
-        </p:nvSpPr>
-        <p:spPr>
-          <a:xfrm>
-            <a:off x="274320" y="1463040"/>
-            <a:ext cx="4160520" cy="731520"/>
-          </a:xfrm>
-          <a:prstGeom prst="rect">
-            <a:avLst/>
-          </a:prstGeom>
-          <a:noFill/>
-          <a:ln/>
-        </p:spPr>
-        <p:txBody>
-          <a:bodyPr wrap="square" lIns="0" tIns="0" rIns="0" bIns="0" rtlCol="0" anchor="ctr"/>
-          <a:lstStyle/>
-          <a:p>
-            <a:pPr algn="ctr" indent="0" marL="0">
-              <a:buNone/>
-            </a:pPr>
-            <a:r>
-              <a:rPr lang="en-US" sz="3600" dirty="0">
-                <a:solidFill>
-                  <a:srgbClr val="000000"/>
-                </a:solidFill>
-              </a:rPr>
-              <a:t>📷</a:t>
-            </a:r>
-            <a:endParaRPr lang="en-US" sz="3600" dirty="0"/>
-          </a:p>
-        </p:txBody>
-      </p:sp>
-      <p:sp>
-        <p:nvSpPr>
-          <p:cNvPr id="7" name="Text 5"/>
-          <p:cNvSpPr/>
-          <p:nvPr/>
-        </p:nvSpPr>
-        <p:spPr>
-          <a:xfrm>
-            <a:off x="274320" y="2240280"/>
-            <a:ext cx="4160520" cy="777240"/>
-          </a:xfrm>
-          <a:prstGeom prst="rect">
-            <a:avLst/>
-          </a:prstGeom>
-          <a:noFill/>
-          <a:ln/>
-        </p:spPr>
-        <p:txBody>
-          <a:bodyPr wrap="square" rtlCol="0" anchor="ctr"/>
-          <a:lstStyle/>
-          <a:p>
-            <a:pPr algn="ctr" indent="0" marL="0">
-              <a:buNone/>
-            </a:pPr>
-            <a:r>
-              <a:rPr lang="en-US" sz="1100" i="1" dirty="0">
-                <a:solidFill>
-                  <a:srgbClr val="1E4D8C"/>
-                </a:solidFill>
-              </a:rPr>
-              <a:t>Insertar captura</a:t>
-            </a:r>
-            <a:endParaRPr lang="en-US" sz="1100" dirty="0"/>
-          </a:p>
-          <a:p>
-            <a:pPr algn="ctr" indent="0" marL="0">
-              <a:buNone/>
-            </a:pPr>
-            <a:r>
-              <a:rPr lang="en-US" sz="1100" i="1" dirty="0">
-                <a:solidFill>
-                  <a:srgbClr val="1E4D8C"/>
-                </a:solidFill>
-              </a:rPr>
-              <a:t>del Focus Group</a:t>
-            </a:r>
-            <a:endParaRPr lang="en-US" sz="1100" dirty="0"/>
-          </a:p>
-          <a:p>
-            <a:pPr algn="ctr" indent="0" marL="0">
-              <a:buNone/>
-            </a:pPr>
-            <a:r>
-              <a:rPr lang="en-US" sz="1100" i="1" dirty="0">
-                <a:solidFill>
-                  <a:srgbClr val="1E4D8C"/>
-                </a:solidFill>
-              </a:rPr>
-              <a:t>(Google Meet)</a:t>
-            </a:r>
-            <a:endParaRPr lang="en-US" sz="1100" dirty="0"/>
-          </a:p>
-        </p:txBody>
-      </p:sp>
-      <p:sp>
-        <p:nvSpPr>
-          <p:cNvPr id="8" name="Text 6"/>
+        </p:spPr>
+      </p:sp>
+      <p:sp>
+        <p:nvSpPr>
+          <p:cNvPr id="7" name="Text 4"/>
           <p:cNvSpPr/>
           <p:nvPr/>
         </p:nvSpPr>
@@ -11579,7 +11361,7 @@
       </p:sp>
       <p:sp>
         <p:nvSpPr>
-          <p:cNvPr id="9" name="Shape 7"/>
+          <p:cNvPr id="8" name="Shape 5"/>
           <p:cNvSpPr/>
           <p:nvPr/>
         </p:nvSpPr>
@@ -11613,7 +11395,7 @@
       </p:sp>
       <p:sp>
         <p:nvSpPr>
-          <p:cNvPr id="10" name="Text 8"/>
+          <p:cNvPr id="9" name="Text 6"/>
           <p:cNvSpPr/>
           <p:nvPr/>
         </p:nvSpPr>
@@ -11649,7 +11431,7 @@
       </p:sp>
       <p:sp>
         <p:nvSpPr>
-          <p:cNvPr id="11" name="Text 9"/>
+          <p:cNvPr id="10" name="Text 7"/>
           <p:cNvSpPr/>
           <p:nvPr/>
         </p:nvSpPr>
@@ -11685,7 +11467,7 @@
       </p:sp>
       <p:sp>
         <p:nvSpPr>
-          <p:cNvPr id="12" name="Text 10"/>
+          <p:cNvPr id="11" name="Text 8"/>
           <p:cNvSpPr/>
           <p:nvPr/>
         </p:nvSpPr>
@@ -11721,7 +11503,7 @@
       </p:sp>
       <p:sp>
         <p:nvSpPr>
-          <p:cNvPr id="13" name="Text 11"/>
+          <p:cNvPr id="12" name="Text 9"/>
           <p:cNvSpPr/>
           <p:nvPr/>
         </p:nvSpPr>
@@ -11757,7 +11539,7 @@
       </p:sp>
       <p:sp>
         <p:nvSpPr>
-          <p:cNvPr id="14" name="Text 12"/>
+          <p:cNvPr id="13" name="Text 10"/>
           <p:cNvSpPr/>
           <p:nvPr/>
         </p:nvSpPr>
@@ -11793,7 +11575,7 @@
       </p:sp>
       <p:sp>
         <p:nvSpPr>
-          <p:cNvPr id="15" name="Shape 13"/>
+          <p:cNvPr id="14" name="Shape 11"/>
           <p:cNvSpPr/>
           <p:nvPr/>
         </p:nvSpPr>
@@ -11827,7 +11609,7 @@
       </p:sp>
       <p:sp>
         <p:nvSpPr>
-          <p:cNvPr id="16" name="Text 14"/>
+          <p:cNvPr id="15" name="Text 12"/>
           <p:cNvSpPr/>
           <p:nvPr/>
         </p:nvSpPr>
@@ -11863,7 +11645,7 @@
       </p:sp>
       <p:sp>
         <p:nvSpPr>
-          <p:cNvPr id="17" name="Text 15"/>
+          <p:cNvPr id="16" name="Text 13"/>
           <p:cNvSpPr/>
           <p:nvPr/>
         </p:nvSpPr>
@@ -11899,7 +11681,7 @@
       </p:sp>
       <p:sp>
         <p:nvSpPr>
-          <p:cNvPr id="18" name="Text 16"/>
+          <p:cNvPr id="17" name="Text 14"/>
           <p:cNvSpPr/>
           <p:nvPr/>
         </p:nvSpPr>
@@ -11935,7 +11717,7 @@
       </p:sp>
       <p:sp>
         <p:nvSpPr>
-          <p:cNvPr id="19" name="Text 17"/>
+          <p:cNvPr id="18" name="Text 15"/>
           <p:cNvSpPr/>
           <p:nvPr/>
         </p:nvSpPr>
@@ -11971,7 +11753,7 @@
       </p:sp>
       <p:sp>
         <p:nvSpPr>
-          <p:cNvPr id="20" name="Text 18"/>
+          <p:cNvPr id="19" name="Text 16"/>
           <p:cNvSpPr/>
           <p:nvPr/>
         </p:nvSpPr>
@@ -12007,7 +11789,7 @@
       </p:sp>
       <p:sp>
         <p:nvSpPr>
-          <p:cNvPr id="21" name="Shape 19"/>
+          <p:cNvPr id="20" name="Shape 17"/>
           <p:cNvSpPr/>
           <p:nvPr/>
         </p:nvSpPr>
@@ -12034,7 +11816,7 @@
       </p:sp>
       <p:sp>
         <p:nvSpPr>
-          <p:cNvPr id="22" name="Text 20"/>
+          <p:cNvPr id="21" name="Text 18"/>
           <p:cNvSpPr/>
           <p:nvPr/>
         </p:nvSpPr>

</xml_diff>